<commit_message>
Aplica identidade visual INPASA em todo o pacote estratégico
Tema claro oficial (Azul #124E81 dominante, Ouro #EAA239, semáforo),
tipografia Montserrat, capa em azul sólido com tagline MAIS QUE ENERGIA,
e correção dos códigos oficiais de unidade (NVM->NMT, SDL->SDR).
Regenera PPTX + PDF + 3 imagens do grupo. Logotipo: área reservada
(aguardando arquivos PNG oficiais).

Co-Authored-By: Claude Opus 4.8 <noreply@anthropic.com>
Claude-Session: https://claude.ai/code/session_01JAKYhBZ2VtJTfAk2iunizq
</commit_message>
<xml_diff>
--- a/plano_seguranca/Apresentacao_Estrategica_Correias_INPASA.pptx
+++ b/plano_seguranca/Apresentacao_Estrategica_Correias_INPASA.pptx
@@ -3107,7 +3107,7 @@
             <a:avLst/>
           </a:prstGeom>
           <a:solidFill>
-            <a:srgbClr val="0F0F1A"/>
+            <a:srgbClr val="124E81"/>
           </a:solidFill>
           <a:ln>
             <a:noFill/>
@@ -3144,14 +3144,14 @@
         </p:nvSpPr>
         <p:spPr>
           <a:xfrm>
-            <a:off x="0" y="4160520"/>
-            <a:ext cx="12191695" cy="45720"/>
+            <a:off x="0" y="0"/>
+            <a:ext cx="12191695" cy="320040"/>
           </a:xfrm>
           <a:prstGeom prst="rect">
             <a:avLst/>
           </a:prstGeom>
           <a:solidFill>
-            <a:srgbClr val="F97316"/>
+            <a:srgbClr val="FFA32A"/>
           </a:solidFill>
           <a:ln>
             <a:noFill/>
@@ -3188,7 +3188,7 @@
         </p:nvSpPr>
         <p:spPr>
           <a:xfrm>
-            <a:off x="822960" y="1371600"/>
+            <a:off x="822960" y="1234440"/>
             <a:ext cx="10515600" cy="457200"/>
           </a:xfrm>
           <a:prstGeom prst="rect">
@@ -3204,13 +3204,13 @@
           <a:p>
             <a:pPr algn="l"/>
             <a:r>
-              <a:rPr sz="1500" b="1">
-                <a:solidFill>
-                  <a:srgbClr val="F97316"/>
-                </a:solidFill>
-                <a:latin typeface="Inter"/>
-              </a:rPr>
-              <a:t>🏭  INPASA  •  APRESENTAÇÃO À DIRETORIA</a:t>
+              <a:rPr sz="1500" b="1" i="0">
+                <a:solidFill>
+                  <a:srgbClr val="EAA239"/>
+                </a:solidFill>
+                <a:latin typeface="Montserrat"/>
+              </a:rPr>
+              <a:t>APRESENTAÇÃO À DIRETORIA</a:t>
             </a:r>
           </a:p>
         </p:txBody>
@@ -3223,7 +3223,7 @@
         </p:nvSpPr>
         <p:spPr>
           <a:xfrm>
-            <a:off x="822960" y="2057400"/>
+            <a:off x="822960" y="1920240"/>
             <a:ext cx="10607040" cy="1645920"/>
           </a:xfrm>
           <a:prstGeom prst="rect">
@@ -3243,11 +3243,11 @@
               </a:lnSpc>
             </a:pPr>
             <a:r>
-              <a:rPr sz="4400" b="1">
+              <a:rPr sz="4400" b="1" i="0">
                 <a:solidFill>
                   <a:srgbClr val="FFFFFF"/>
                 </a:solidFill>
-                <a:latin typeface="Inter"/>
+                <a:latin typeface="Montserrat"/>
               </a:rPr>
               <a:t>Plano de Substituição de</a:t>
             </a:r>
@@ -3259,11 +3259,11 @@
               </a:lnSpc>
             </a:pPr>
             <a:r>
-              <a:rPr sz="4400" b="1">
+              <a:rPr sz="4400" b="1" i="0">
                 <a:solidFill>
                   <a:srgbClr val="FFFFFF"/>
                 </a:solidFill>
-                <a:latin typeface="Inter"/>
+                <a:latin typeface="Montserrat"/>
               </a:rPr>
               <a:t>Correias Transportadoras</a:t>
             </a:r>
@@ -3278,8 +3278,8 @@
         </p:nvSpPr>
         <p:spPr>
           <a:xfrm>
-            <a:off x="822960" y="4343400"/>
-            <a:ext cx="10607040" cy="914400"/>
+            <a:off x="822960" y="4160520"/>
+            <a:ext cx="10607040" cy="822960"/>
           </a:xfrm>
           <a:prstGeom prst="rect">
             <a:avLst/>
@@ -3298,11 +3298,11 @@
               </a:lnSpc>
             </a:pPr>
             <a:r>
-              <a:rPr sz="1700" b="0">
-                <a:solidFill>
-                  <a:srgbClr val="9CA3AF"/>
-                </a:solidFill>
-                <a:latin typeface="Inter"/>
+              <a:rPr sz="1600" b="0" i="0">
+                <a:solidFill>
+                  <a:srgbClr val="C7D6E6"/>
+                </a:solidFill>
+                <a:latin typeface="Montserrat"/>
               </a:rPr>
               <a:t>Status do programa e cronograma de regularização por unidade</a:t>
             </a:r>
@@ -3314,27 +3314,71 @@
               </a:lnSpc>
             </a:pPr>
             <a:r>
-              <a:rPr sz="1700" b="0">
-                <a:solidFill>
-                  <a:srgbClr val="9CA3AF"/>
-                </a:solidFill>
-                <a:latin typeface="Inter"/>
-              </a:rPr>
-              <a:t>Nova Mutum • Sinop • Sidrolândia • Balsas</a:t>
-            </a:r>
-          </a:p>
-        </p:txBody>
-      </p:sp>
-      <p:sp>
-        <p:nvSpPr>
-          <p:cNvPr id="7" name="TextBox 6"/>
+              <a:rPr sz="1600" b="0" i="0">
+                <a:solidFill>
+                  <a:srgbClr val="C7D6E6"/>
+                </a:solidFill>
+                <a:latin typeface="Montserrat"/>
+              </a:rPr>
+              <a:t>Nova Mutum · Sinop · Sidrolândia · Balsas</a:t>
+            </a:r>
+          </a:p>
+        </p:txBody>
+      </p:sp>
+      <p:sp>
+        <p:nvSpPr>
+          <p:cNvPr id="7" name="Rectangle 6"/>
+          <p:cNvSpPr/>
+          <p:nvPr/>
+        </p:nvSpPr>
+        <p:spPr>
+          <a:xfrm>
+            <a:off x="822960" y="5257800"/>
+            <a:ext cx="2743200" cy="25400"/>
+          </a:xfrm>
+          <a:prstGeom prst="rect">
+            <a:avLst/>
+          </a:prstGeom>
+          <a:solidFill>
+            <a:srgbClr val="FFA32A"/>
+          </a:solidFill>
+          <a:ln>
+            <a:noFill/>
+          </a:ln>
+          <a:effectLst/>
+        </p:spPr>
+        <p:style>
+          <a:lnRef idx="1">
+            <a:schemeClr val="accent1"/>
+          </a:lnRef>
+          <a:fillRef idx="3">
+            <a:schemeClr val="accent1"/>
+          </a:fillRef>
+          <a:effectRef idx="2">
+            <a:schemeClr val="accent1"/>
+          </a:effectRef>
+          <a:fontRef idx="minor">
+            <a:schemeClr val="lt1"/>
+          </a:fontRef>
+        </p:style>
+        <p:txBody>
+          <a:bodyPr rtlCol="0" anchor="ctr"/>
+          <a:lstStyle/>
+          <a:p>
+            <a:pPr algn="ctr"/>
+          </a:p>
+        </p:txBody>
+      </p:sp>
+      <p:sp>
+        <p:nvSpPr>
+          <p:cNvPr id="8" name="TextBox 7"/>
           <p:cNvSpPr txBox="1"/>
           <p:nvPr/>
         </p:nvSpPr>
         <p:spPr>
           <a:xfrm>
-            <a:off x="822960" y="5989320"/>
-            <a:ext cx="10607040" cy="457200"/>
+            <a:off x="822960" y="5440680"/>
+            <a:ext cx="10058400" cy="457200"/>
           </a:xfrm>
           <a:prstGeom prst="rect">
             <a:avLst/>
@@ -3349,13 +3393,48 @@
           <a:p>
             <a:pPr algn="l"/>
             <a:r>
-              <a:rPr sz="1200" b="0">
-                <a:solidFill>
-                  <a:srgbClr val="6B7280"/>
-                </a:solidFill>
-                <a:latin typeface="Inter"/>
-              </a:rPr>
-              <a:t>Base: levantamento FLEXLAB (jun/2026) + plano de execução  |  Data de referência: 02/07/2026</a:t>
+              <a:rPr sz="1800" b="1" i="1">
+                <a:solidFill>
+                  <a:srgbClr val="EAA239"/>
+                </a:solidFill>
+                <a:latin typeface="Montserrat"/>
+              </a:rPr>
+              <a:t>MAIS QUE ENERGIA</a:t>
+            </a:r>
+          </a:p>
+        </p:txBody>
+      </p:sp>
+      <p:sp>
+        <p:nvSpPr>
+          <p:cNvPr id="9" name="TextBox 8"/>
+          <p:cNvSpPr txBox="1"/>
+          <p:nvPr/>
+        </p:nvSpPr>
+        <p:spPr>
+          <a:xfrm>
+            <a:off x="822960" y="6126480"/>
+            <a:ext cx="10607040" cy="365760"/>
+          </a:xfrm>
+          <a:prstGeom prst="rect">
+            <a:avLst/>
+          </a:prstGeom>
+          <a:noFill/>
+        </p:spPr>
+        <p:txBody>
+          <a:bodyPr wrap="square" anchor="t" lIns="25400" rIns="25400">
+            <a:spAutoFit/>
+          </a:bodyPr>
+          <a:lstStyle/>
+          <a:p>
+            <a:pPr algn="l"/>
+            <a:r>
+              <a:rPr sz="1100" b="0" i="0">
+                <a:solidFill>
+                  <a:srgbClr val="9FB4C9"/>
+                </a:solidFill>
+                <a:latin typeface="Montserrat"/>
+              </a:rPr>
+              <a:t>Base: levantamento FLEXLAB (jun/2026) + plano de execução  |  ref. 02/07/2026</a:t>
             </a:r>
           </a:p>
         </p:txBody>
@@ -3393,7 +3472,7 @@
             <a:avLst/>
           </a:prstGeom>
           <a:solidFill>
-            <a:srgbClr val="0F0F1A"/>
+            <a:srgbClr val="FFFFFF"/>
           </a:solidFill>
           <a:ln>
             <a:noFill/>
@@ -3431,13 +3510,13 @@
         <p:spPr>
           <a:xfrm>
             <a:off x="0" y="0"/>
-            <a:ext cx="12191695" cy="1097280"/>
+            <a:ext cx="12191695" cy="1051560"/>
           </a:xfrm>
           <a:prstGeom prst="rect">
             <a:avLst/>
           </a:prstGeom>
           <a:solidFill>
-            <a:srgbClr val="1E1E30"/>
+            <a:srgbClr val="124E81"/>
           </a:solidFill>
           <a:ln>
             <a:noFill/>
@@ -3474,14 +3553,14 @@
         </p:nvSpPr>
         <p:spPr>
           <a:xfrm>
-            <a:off x="0" y="1097280"/>
-            <a:ext cx="12191695" cy="36576"/>
+            <a:off x="0" y="1051560"/>
+            <a:ext cx="12191695" cy="45720"/>
           </a:xfrm>
           <a:prstGeom prst="rect">
             <a:avLst/>
           </a:prstGeom>
           <a:solidFill>
-            <a:srgbClr val="F97316"/>
+            <a:srgbClr val="FFA32A"/>
           </a:solidFill>
           <a:ln>
             <a:noFill/>
@@ -3534,11 +3613,11 @@
           <a:p>
             <a:pPr algn="l"/>
             <a:r>
-              <a:rPr sz="1200" b="1">
-                <a:solidFill>
-                  <a:srgbClr val="F97316"/>
-                </a:solidFill>
-                <a:latin typeface="Inter"/>
+              <a:rPr sz="1200" b="1" i="0">
+                <a:solidFill>
+                  <a:srgbClr val="EAA239"/>
+                </a:solidFill>
+                <a:latin typeface="Montserrat"/>
               </a:rPr>
               <a:t>A PERGUNTA DA DIRETORIA</a:t>
             </a:r>
@@ -3553,8 +3632,8 @@
         </p:nvSpPr>
         <p:spPr>
           <a:xfrm>
-            <a:off x="502920" y="420624"/>
-            <a:ext cx="11155680" cy="548640"/>
+            <a:off x="502920" y="402336"/>
+            <a:ext cx="11155680" cy="566928"/>
           </a:xfrm>
           <a:prstGeom prst="rect">
             <a:avLst/>
@@ -3569,11 +3648,11 @@
           <a:p>
             <a:pPr algn="l"/>
             <a:r>
-              <a:rPr sz="2500" b="1">
+              <a:rPr sz="2500" b="1" i="0">
                 <a:solidFill>
                   <a:srgbClr val="FFFFFF"/>
                 </a:solidFill>
-                <a:latin typeface="Inter"/>
+                <a:latin typeface="Montserrat"/>
               </a:rPr>
               <a:t>Quando cada unidade estará regularizada?</a:t>
             </a:r>
@@ -3589,17 +3668,17 @@
         <p:spPr>
           <a:xfrm>
             <a:off x="502920" y="1325880"/>
-            <a:ext cx="11201400" cy="777240"/>
+            <a:ext cx="11201400" cy="731520"/>
           </a:xfrm>
           <a:prstGeom prst="roundRect">
             <a:avLst/>
           </a:prstGeom>
           <a:solidFill>
-            <a:srgbClr val="252538"/>
+            <a:srgbClr val="F2F5F8"/>
           </a:solidFill>
           <a:ln w="15875">
             <a:solidFill>
-              <a:srgbClr val="F97316"/>
+              <a:srgbClr val="124E81"/>
             </a:solidFill>
           </a:ln>
           <a:effectLst/>
@@ -3635,7 +3714,7 @@
         <p:spPr>
           <a:xfrm>
             <a:off x="731520" y="1325880"/>
-            <a:ext cx="10789920" cy="777240"/>
+            <a:ext cx="10789920" cy="731520"/>
           </a:xfrm>
           <a:prstGeom prst="rect">
             <a:avLst/>
@@ -3650,13 +3729,13 @@
           <a:p>
             <a:pPr algn="l"/>
             <a:r>
-              <a:rPr sz="1500" b="1">
-                <a:solidFill>
-                  <a:srgbClr val="FFFFFF"/>
-                </a:solidFill>
-                <a:latin typeface="Inter"/>
-              </a:rPr>
-              <a:t>Programa concluído em  30/12/2026    |    46 correias  •  3 já concluídas  •  7 urgentes (&lt;=30 dias)  •  0 vencidas</a:t>
+              <a:rPr sz="1500" b="1" i="0">
+                <a:solidFill>
+                  <a:srgbClr val="124E81"/>
+                </a:solidFill>
+                <a:latin typeface="Montserrat"/>
+              </a:rPr>
+              <a:t>Programa concluído em 30/12/2026    |    46 correias · 3 concluídas · 7 urgentes (&lt;=30 dias) · 0 vencidas</a:t>
             </a:r>
           </a:p>
         </p:txBody>
@@ -3669,14 +3748,14 @@
         </p:nvSpPr>
         <p:spPr>
           <a:xfrm>
-            <a:off x="502920" y="2331720"/>
-            <a:ext cx="2697480" cy="2880360"/>
+            <a:off x="502920" y="2286000"/>
+            <a:ext cx="2697480" cy="2926080"/>
           </a:xfrm>
           <a:prstGeom prst="roundRect">
             <a:avLst/>
           </a:prstGeom>
           <a:solidFill>
-            <a:srgbClr val="1E1E30"/>
+            <a:srgbClr val="F2F5F8"/>
           </a:solidFill>
           <a:ln>
             <a:noFill/>
@@ -3713,14 +3792,14 @@
         </p:nvSpPr>
         <p:spPr>
           <a:xfrm>
-            <a:off x="502920" y="2331720"/>
-            <a:ext cx="2697480" cy="109728"/>
+            <a:off x="502920" y="2286000"/>
+            <a:ext cx="2697480" cy="118872"/>
           </a:xfrm>
           <a:prstGeom prst="rect">
             <a:avLst/>
           </a:prstGeom>
           <a:solidFill>
-            <a:srgbClr val="3B82F6"/>
+            <a:srgbClr val="124E81"/>
           </a:solidFill>
           <a:ln>
             <a:noFill/>
@@ -3757,7 +3836,7 @@
         </p:nvSpPr>
         <p:spPr>
           <a:xfrm>
-            <a:off x="685800" y="2587752"/>
+            <a:off x="685800" y="2560320"/>
             <a:ext cx="2331720" cy="365760"/>
           </a:xfrm>
           <a:prstGeom prst="rect">
@@ -3773,13 +3852,13 @@
           <a:p>
             <a:pPr algn="l"/>
             <a:r>
-              <a:rPr sz="1300" b="1">
-                <a:solidFill>
-                  <a:srgbClr val="3B82F6"/>
-                </a:solidFill>
-                <a:latin typeface="Inter"/>
-              </a:rPr>
-              <a:t>NVM</a:t>
+              <a:rPr sz="1300" b="1" i="0">
+                <a:solidFill>
+                  <a:srgbClr val="124E81"/>
+                </a:solidFill>
+                <a:latin typeface="Montserrat"/>
+              </a:rPr>
+              <a:t>NMT</a:t>
             </a:r>
           </a:p>
         </p:txBody>
@@ -3792,7 +3871,7 @@
         </p:nvSpPr>
         <p:spPr>
           <a:xfrm>
-            <a:off x="685800" y="2898648"/>
+            <a:off x="685800" y="2871216"/>
             <a:ext cx="2331720" cy="457200"/>
           </a:xfrm>
           <a:prstGeom prst="rect">
@@ -3808,11 +3887,11 @@
           <a:p>
             <a:pPr algn="l"/>
             <a:r>
-              <a:rPr sz="1500" b="1">
-                <a:solidFill>
-                  <a:srgbClr val="FFFFFF"/>
-                </a:solidFill>
-                <a:latin typeface="Inter"/>
+              <a:rPr sz="1500" b="1" i="0">
+                <a:solidFill>
+                  <a:srgbClr val="20303F"/>
+                </a:solidFill>
+                <a:latin typeface="Montserrat"/>
               </a:rPr>
               <a:t>Nova Mutum</a:t>
             </a:r>
@@ -3827,7 +3906,7 @@
         </p:nvSpPr>
         <p:spPr>
           <a:xfrm>
-            <a:off x="685800" y="3383280"/>
+            <a:off x="685800" y="3364992"/>
             <a:ext cx="2331720" cy="320040"/>
           </a:xfrm>
           <a:prstGeom prst="rect">
@@ -3843,11 +3922,11 @@
           <a:p>
             <a:pPr algn="l"/>
             <a:r>
-              <a:rPr sz="1000" b="1">
-                <a:solidFill>
-                  <a:srgbClr val="9CA3AF"/>
-                </a:solidFill>
-                <a:latin typeface="Inter"/>
+              <a:rPr sz="1000" b="1" i="0">
+                <a:solidFill>
+                  <a:srgbClr val="6B7885"/>
+                </a:solidFill>
+                <a:latin typeface="Montserrat"/>
               </a:rPr>
               <a:t>CONCLUÍDA EM</a:t>
             </a:r>
@@ -3862,7 +3941,7 @@
         </p:nvSpPr>
         <p:spPr>
           <a:xfrm>
-            <a:off x="685800" y="3630168"/>
+            <a:off x="685800" y="3611880"/>
             <a:ext cx="2331720" cy="502920"/>
           </a:xfrm>
           <a:prstGeom prst="rect">
@@ -3878,11 +3957,11 @@
           <a:p>
             <a:pPr algn="l"/>
             <a:r>
-              <a:rPr sz="2200" b="1">
-                <a:solidFill>
-                  <a:srgbClr val="3B82F6"/>
-                </a:solidFill>
-                <a:latin typeface="Inter"/>
+              <a:rPr sz="2200" b="1" i="0">
+                <a:solidFill>
+                  <a:srgbClr val="124E81"/>
+                </a:solidFill>
+                <a:latin typeface="Montserrat"/>
               </a:rPr>
               <a:t>22/10/2026</a:t>
             </a:r>
@@ -3897,7 +3976,7 @@
         </p:nvSpPr>
         <p:spPr>
           <a:xfrm>
-            <a:off x="685800" y="4206239"/>
+            <a:off x="685800" y="4206240"/>
             <a:ext cx="2331720" cy="914400"/>
           </a:xfrm>
           <a:prstGeom prst="rect">
@@ -3917,13 +3996,13 @@
               </a:lnSpc>
             </a:pPr>
             <a:r>
-              <a:rPr sz="1050" b="0">
-                <a:solidFill>
-                  <a:srgbClr val="E0E0E0"/>
-                </a:solidFill>
-                <a:latin typeface="Inter"/>
-              </a:rPr>
-              <a:t>16 correias no plano; 1 já concluída. Última substituição em 22/10/2026.</a:t>
+              <a:rPr sz="1050" b="0" i="0">
+                <a:solidFill>
+                  <a:srgbClr val="20303F"/>
+                </a:solidFill>
+                <a:latin typeface="Montserrat"/>
+              </a:rPr>
+              <a:t>16 correias no plano; 1 concluída. Última substituição em 22/10/2026.</a:t>
             </a:r>
           </a:p>
         </p:txBody>
@@ -3936,14 +4015,14 @@
         </p:nvSpPr>
         <p:spPr>
           <a:xfrm>
-            <a:off x="3319272" y="2331720"/>
-            <a:ext cx="2697480" cy="2880360"/>
+            <a:off x="3319272" y="2286000"/>
+            <a:ext cx="2697480" cy="2926080"/>
           </a:xfrm>
           <a:prstGeom prst="roundRect">
             <a:avLst/>
           </a:prstGeom>
           <a:solidFill>
-            <a:srgbClr val="1E1E30"/>
+            <a:srgbClr val="F2F5F8"/>
           </a:solidFill>
           <a:ln>
             <a:noFill/>
@@ -3980,14 +4059,14 @@
         </p:nvSpPr>
         <p:spPr>
           <a:xfrm>
-            <a:off x="3319272" y="2331720"/>
-            <a:ext cx="2697480" cy="109728"/>
+            <a:off x="3319272" y="2286000"/>
+            <a:ext cx="2697480" cy="118872"/>
           </a:xfrm>
           <a:prstGeom prst="rect">
             <a:avLst/>
           </a:prstGeom>
           <a:solidFill>
-            <a:srgbClr val="F97316"/>
+            <a:srgbClr val="EAA239"/>
           </a:solidFill>
           <a:ln>
             <a:noFill/>
@@ -4024,7 +4103,7 @@
         </p:nvSpPr>
         <p:spPr>
           <a:xfrm>
-            <a:off x="3502152" y="2587752"/>
+            <a:off x="3502152" y="2560320"/>
             <a:ext cx="2331720" cy="365760"/>
           </a:xfrm>
           <a:prstGeom prst="rect">
@@ -4040,11 +4119,11 @@
           <a:p>
             <a:pPr algn="l"/>
             <a:r>
-              <a:rPr sz="1300" b="1">
-                <a:solidFill>
-                  <a:srgbClr val="F97316"/>
-                </a:solidFill>
-                <a:latin typeface="Inter"/>
+              <a:rPr sz="1300" b="1" i="0">
+                <a:solidFill>
+                  <a:srgbClr val="EAA239"/>
+                </a:solidFill>
+                <a:latin typeface="Montserrat"/>
               </a:rPr>
               <a:t>SNP</a:t>
             </a:r>
@@ -4059,7 +4138,7 @@
         </p:nvSpPr>
         <p:spPr>
           <a:xfrm>
-            <a:off x="3502152" y="2898648"/>
+            <a:off x="3502152" y="2871216"/>
             <a:ext cx="2331720" cy="457200"/>
           </a:xfrm>
           <a:prstGeom prst="rect">
@@ -4075,11 +4154,11 @@
           <a:p>
             <a:pPr algn="l"/>
             <a:r>
-              <a:rPr sz="1500" b="1">
-                <a:solidFill>
-                  <a:srgbClr val="FFFFFF"/>
-                </a:solidFill>
-                <a:latin typeface="Inter"/>
+              <a:rPr sz="1500" b="1" i="0">
+                <a:solidFill>
+                  <a:srgbClr val="20303F"/>
+                </a:solidFill>
+                <a:latin typeface="Montserrat"/>
               </a:rPr>
               <a:t>Sinop</a:t>
             </a:r>
@@ -4094,7 +4173,7 @@
         </p:nvSpPr>
         <p:spPr>
           <a:xfrm>
-            <a:off x="3502152" y="3383280"/>
+            <a:off x="3502152" y="3364992"/>
             <a:ext cx="2331720" cy="320040"/>
           </a:xfrm>
           <a:prstGeom prst="rect">
@@ -4110,11 +4189,11 @@
           <a:p>
             <a:pPr algn="l"/>
             <a:r>
-              <a:rPr sz="1000" b="1">
-                <a:solidFill>
-                  <a:srgbClr val="9CA3AF"/>
-                </a:solidFill>
-                <a:latin typeface="Inter"/>
+              <a:rPr sz="1000" b="1" i="0">
+                <a:solidFill>
+                  <a:srgbClr val="6B7885"/>
+                </a:solidFill>
+                <a:latin typeface="Montserrat"/>
               </a:rPr>
               <a:t>CONCLUÍDA EM</a:t>
             </a:r>
@@ -4129,7 +4208,7 @@
         </p:nvSpPr>
         <p:spPr>
           <a:xfrm>
-            <a:off x="3502152" y="3630168"/>
+            <a:off x="3502152" y="3611880"/>
             <a:ext cx="2331720" cy="502920"/>
           </a:xfrm>
           <a:prstGeom prst="rect">
@@ -4145,11 +4224,11 @@
           <a:p>
             <a:pPr algn="l"/>
             <a:r>
-              <a:rPr sz="2200" b="1">
-                <a:solidFill>
-                  <a:srgbClr val="F97316"/>
-                </a:solidFill>
-                <a:latin typeface="Inter"/>
+              <a:rPr sz="2200" b="1" i="0">
+                <a:solidFill>
+                  <a:srgbClr val="EAA239"/>
+                </a:solidFill>
+                <a:latin typeface="Montserrat"/>
               </a:rPr>
               <a:t>30/12/2026</a:t>
             </a:r>
@@ -4164,7 +4243,7 @@
         </p:nvSpPr>
         <p:spPr>
           <a:xfrm>
-            <a:off x="3502152" y="4206239"/>
+            <a:off x="3502152" y="4206240"/>
             <a:ext cx="2331720" cy="914400"/>
           </a:xfrm>
           <a:prstGeom prst="rect">
@@ -4184,13 +4263,13 @@
               </a:lnSpc>
             </a:pPr>
             <a:r>
-              <a:rPr sz="1050" b="0">
-                <a:solidFill>
-                  <a:srgbClr val="E0E0E0"/>
-                </a:solidFill>
-                <a:latin typeface="Inter"/>
-              </a:rPr>
-              <a:t>23 correias no plano; 1 já concluída. Última em 30/12/2026 (esteiras de cavacos).</a:t>
+              <a:rPr sz="1050" b="0" i="0">
+                <a:solidFill>
+                  <a:srgbClr val="20303F"/>
+                </a:solidFill>
+                <a:latin typeface="Montserrat"/>
+              </a:rPr>
+              <a:t>23 correias no plano; 1 concluída. Última em 30/12/2026 (esteiras de cavacos).</a:t>
             </a:r>
           </a:p>
         </p:txBody>
@@ -4203,14 +4282,14 @@
         </p:nvSpPr>
         <p:spPr>
           <a:xfrm>
-            <a:off x="6135624" y="2331720"/>
-            <a:ext cx="2697480" cy="2880360"/>
+            <a:off x="6135624" y="2286000"/>
+            <a:ext cx="2697480" cy="2926080"/>
           </a:xfrm>
           <a:prstGeom prst="roundRect">
             <a:avLst/>
           </a:prstGeom>
           <a:solidFill>
-            <a:srgbClr val="1E1E30"/>
+            <a:srgbClr val="F2F5F8"/>
           </a:solidFill>
           <a:ln>
             <a:noFill/>
@@ -4247,14 +4326,14 @@
         </p:nvSpPr>
         <p:spPr>
           <a:xfrm>
-            <a:off x="6135624" y="2331720"/>
-            <a:ext cx="2697480" cy="109728"/>
+            <a:off x="6135624" y="2286000"/>
+            <a:ext cx="2697480" cy="118872"/>
           </a:xfrm>
           <a:prstGeom prst="rect">
             <a:avLst/>
           </a:prstGeom>
           <a:solidFill>
-            <a:srgbClr val="22C55E"/>
+            <a:srgbClr val="007D77"/>
           </a:solidFill>
           <a:ln>
             <a:noFill/>
@@ -4291,7 +4370,7 @@
         </p:nvSpPr>
         <p:spPr>
           <a:xfrm>
-            <a:off x="6318504" y="2587752"/>
+            <a:off x="6318504" y="2560320"/>
             <a:ext cx="2331720" cy="365760"/>
           </a:xfrm>
           <a:prstGeom prst="rect">
@@ -4307,13 +4386,13 @@
           <a:p>
             <a:pPr algn="l"/>
             <a:r>
-              <a:rPr sz="1300" b="1">
-                <a:solidFill>
-                  <a:srgbClr val="22C55E"/>
-                </a:solidFill>
-                <a:latin typeface="Inter"/>
-              </a:rPr>
-              <a:t>SDL</a:t>
+              <a:rPr sz="1300" b="1" i="0">
+                <a:solidFill>
+                  <a:srgbClr val="007D77"/>
+                </a:solidFill>
+                <a:latin typeface="Montserrat"/>
+              </a:rPr>
+              <a:t>SDR</a:t>
             </a:r>
           </a:p>
         </p:txBody>
@@ -4326,7 +4405,7 @@
         </p:nvSpPr>
         <p:spPr>
           <a:xfrm>
-            <a:off x="6318504" y="2898648"/>
+            <a:off x="6318504" y="2871216"/>
             <a:ext cx="2331720" cy="457200"/>
           </a:xfrm>
           <a:prstGeom prst="rect">
@@ -4342,11 +4421,11 @@
           <a:p>
             <a:pPr algn="l"/>
             <a:r>
-              <a:rPr sz="1500" b="1">
-                <a:solidFill>
-                  <a:srgbClr val="FFFFFF"/>
-                </a:solidFill>
-                <a:latin typeface="Inter"/>
+              <a:rPr sz="1500" b="1" i="0">
+                <a:solidFill>
+                  <a:srgbClr val="20303F"/>
+                </a:solidFill>
+                <a:latin typeface="Montserrat"/>
               </a:rPr>
               <a:t>Sidrolândia</a:t>
             </a:r>
@@ -4361,7 +4440,7 @@
         </p:nvSpPr>
         <p:spPr>
           <a:xfrm>
-            <a:off x="6318504" y="3383280"/>
+            <a:off x="6318504" y="3364992"/>
             <a:ext cx="2331720" cy="320040"/>
           </a:xfrm>
           <a:prstGeom prst="rect">
@@ -4377,11 +4456,11 @@
           <a:p>
             <a:pPr algn="l"/>
             <a:r>
-              <a:rPr sz="1000" b="1">
-                <a:solidFill>
-                  <a:srgbClr val="9CA3AF"/>
-                </a:solidFill>
-                <a:latin typeface="Inter"/>
+              <a:rPr sz="1000" b="1" i="0">
+                <a:solidFill>
+                  <a:srgbClr val="6B7885"/>
+                </a:solidFill>
+                <a:latin typeface="Montserrat"/>
               </a:rPr>
               <a:t>CONCLUÍDA EM</a:t>
             </a:r>
@@ -4396,7 +4475,7 @@
         </p:nvSpPr>
         <p:spPr>
           <a:xfrm>
-            <a:off x="6318504" y="3630168"/>
+            <a:off x="6318504" y="3611880"/>
             <a:ext cx="2331720" cy="502920"/>
           </a:xfrm>
           <a:prstGeom prst="rect">
@@ -4412,11 +4491,11 @@
           <a:p>
             <a:pPr algn="l"/>
             <a:r>
-              <a:rPr sz="2200" b="1">
-                <a:solidFill>
-                  <a:srgbClr val="22C55E"/>
-                </a:solidFill>
-                <a:latin typeface="Inter"/>
+              <a:rPr sz="2200" b="1" i="0">
+                <a:solidFill>
+                  <a:srgbClr val="007D77"/>
+                </a:solidFill>
+                <a:latin typeface="Montserrat"/>
               </a:rPr>
               <a:t>30/09/2026</a:t>
             </a:r>
@@ -4431,7 +4510,7 @@
         </p:nvSpPr>
         <p:spPr>
           <a:xfrm>
-            <a:off x="6318504" y="4206239"/>
+            <a:off x="6318504" y="4206240"/>
             <a:ext cx="2331720" cy="914400"/>
           </a:xfrm>
           <a:prstGeom prst="rect">
@@ -4451,11 +4530,11 @@
               </a:lnSpc>
             </a:pPr>
             <a:r>
-              <a:rPr sz="1050" b="0">
-                <a:solidFill>
-                  <a:srgbClr val="E0E0E0"/>
-                </a:solidFill>
-                <a:latin typeface="Inter"/>
+              <a:rPr sz="1050" b="0" i="0">
+                <a:solidFill>
+                  <a:srgbClr val="20303F"/>
+                </a:solidFill>
+                <a:latin typeface="Montserrat"/>
               </a:rPr>
               <a:t>2 correias no plano. Ambas concluídas até 30/09/2026.</a:t>
             </a:r>
@@ -4470,14 +4549,14 @@
         </p:nvSpPr>
         <p:spPr>
           <a:xfrm>
-            <a:off x="8951976" y="2331720"/>
-            <a:ext cx="2697480" cy="2880360"/>
+            <a:off x="8951976" y="2286000"/>
+            <a:ext cx="2697480" cy="2926080"/>
           </a:xfrm>
           <a:prstGeom prst="roundRect">
             <a:avLst/>
           </a:prstGeom>
           <a:solidFill>
-            <a:srgbClr val="1E1E30"/>
+            <a:srgbClr val="F2F5F8"/>
           </a:solidFill>
           <a:ln>
             <a:noFill/>
@@ -4514,14 +4593,14 @@
         </p:nvSpPr>
         <p:spPr>
           <a:xfrm>
-            <a:off x="8951976" y="2331720"/>
-            <a:ext cx="2697480" cy="109728"/>
+            <a:off x="8951976" y="2286000"/>
+            <a:ext cx="2697480" cy="118872"/>
           </a:xfrm>
           <a:prstGeom prst="rect">
             <a:avLst/>
           </a:prstGeom>
           <a:solidFill>
-            <a:srgbClr val="A855F7"/>
+            <a:srgbClr val="007CC5"/>
           </a:solidFill>
           <a:ln>
             <a:noFill/>
@@ -4558,7 +4637,7 @@
         </p:nvSpPr>
         <p:spPr>
           <a:xfrm>
-            <a:off x="9134856" y="2587752"/>
+            <a:off x="9134856" y="2560320"/>
             <a:ext cx="2331720" cy="365760"/>
           </a:xfrm>
           <a:prstGeom prst="rect">
@@ -4574,11 +4653,11 @@
           <a:p>
             <a:pPr algn="l"/>
             <a:r>
-              <a:rPr sz="1300" b="1">
-                <a:solidFill>
-                  <a:srgbClr val="A855F7"/>
-                </a:solidFill>
-                <a:latin typeface="Inter"/>
+              <a:rPr sz="1300" b="1" i="0">
+                <a:solidFill>
+                  <a:srgbClr val="007CC5"/>
+                </a:solidFill>
+                <a:latin typeface="Montserrat"/>
               </a:rPr>
               <a:t>BLS</a:t>
             </a:r>
@@ -4593,7 +4672,7 @@
         </p:nvSpPr>
         <p:spPr>
           <a:xfrm>
-            <a:off x="9134856" y="2898648"/>
+            <a:off x="9134856" y="2871216"/>
             <a:ext cx="2331720" cy="457200"/>
           </a:xfrm>
           <a:prstGeom prst="rect">
@@ -4609,11 +4688,11 @@
           <a:p>
             <a:pPr algn="l"/>
             <a:r>
-              <a:rPr sz="1500" b="1">
-                <a:solidFill>
-                  <a:srgbClr val="FFFFFF"/>
-                </a:solidFill>
-                <a:latin typeface="Inter"/>
+              <a:rPr sz="1500" b="1" i="0">
+                <a:solidFill>
+                  <a:srgbClr val="20303F"/>
+                </a:solidFill>
+                <a:latin typeface="Montserrat"/>
               </a:rPr>
               <a:t>Balsas</a:t>
             </a:r>
@@ -4628,7 +4707,7 @@
         </p:nvSpPr>
         <p:spPr>
           <a:xfrm>
-            <a:off x="9134856" y="3383280"/>
+            <a:off x="9134856" y="3364992"/>
             <a:ext cx="2331720" cy="320040"/>
           </a:xfrm>
           <a:prstGeom prst="rect">
@@ -4644,11 +4723,11 @@
           <a:p>
             <a:pPr algn="l"/>
             <a:r>
-              <a:rPr sz="1000" b="1">
-                <a:solidFill>
-                  <a:srgbClr val="9CA3AF"/>
-                </a:solidFill>
-                <a:latin typeface="Inter"/>
+              <a:rPr sz="1000" b="1" i="0">
+                <a:solidFill>
+                  <a:srgbClr val="6B7885"/>
+                </a:solidFill>
+                <a:latin typeface="Montserrat"/>
               </a:rPr>
               <a:t>CONCLUÍDA EM</a:t>
             </a:r>
@@ -4663,7 +4742,7 @@
         </p:nvSpPr>
         <p:spPr>
           <a:xfrm>
-            <a:off x="9134856" y="3630168"/>
+            <a:off x="9134856" y="3611880"/>
             <a:ext cx="2331720" cy="502920"/>
           </a:xfrm>
           <a:prstGeom prst="rect">
@@ -4679,11 +4758,11 @@
           <a:p>
             <a:pPr algn="l"/>
             <a:r>
-              <a:rPr sz="2200" b="1">
-                <a:solidFill>
-                  <a:srgbClr val="A855F7"/>
-                </a:solidFill>
-                <a:latin typeface="Inter"/>
+              <a:rPr sz="2200" b="1" i="0">
+                <a:solidFill>
+                  <a:srgbClr val="007CC5"/>
+                </a:solidFill>
+                <a:latin typeface="Montserrat"/>
               </a:rPr>
               <a:t>24/07/2026</a:t>
             </a:r>
@@ -4698,7 +4777,7 @@
         </p:nvSpPr>
         <p:spPr>
           <a:xfrm>
-            <a:off x="9134856" y="4206239"/>
+            <a:off x="9134856" y="4206240"/>
             <a:ext cx="2331720" cy="914400"/>
           </a:xfrm>
           <a:prstGeom prst="rect">
@@ -4718,11 +4797,11 @@
               </a:lnSpc>
             </a:pPr>
             <a:r>
-              <a:rPr sz="1050" b="0">
-                <a:solidFill>
-                  <a:srgbClr val="E0E0E0"/>
-                </a:solidFill>
-                <a:latin typeface="Inter"/>
+              <a:rPr sz="1050" b="0" i="0">
+                <a:solidFill>
+                  <a:srgbClr val="20303F"/>
+                </a:solidFill>
+                <a:latin typeface="Montserrat"/>
               </a:rPr>
               <a:t>4 esteiras + 1 sobressalente; 1 concluída. Esteiras concluídas até 24/07/2026.</a:t>
             </a:r>
@@ -4737,8 +4816,8 @@
         </p:nvSpPr>
         <p:spPr>
           <a:xfrm>
-            <a:off x="502920" y="6446520"/>
-            <a:ext cx="8229600" cy="320040"/>
+            <a:off x="502920" y="6419088"/>
+            <a:ext cx="9144000" cy="320040"/>
           </a:xfrm>
           <a:prstGeom prst="rect">
             <a:avLst/>
@@ -4753,13 +4832,13 @@
           <a:p>
             <a:pPr algn="l"/>
             <a:r>
-              <a:rPr sz="900" b="0">
-                <a:solidFill>
-                  <a:srgbClr val="6B7280"/>
-                </a:solidFill>
-                <a:latin typeface="Inter"/>
-              </a:rPr>
-              <a:t>INPASA  •  Plano de Substituição de Correias Transportadoras  •  ref. 02/07/2026</a:t>
+              <a:rPr sz="900" b="0" i="0">
+                <a:solidFill>
+                  <a:srgbClr val="6B7885"/>
+                </a:solidFill>
+                <a:latin typeface="Montserrat"/>
+              </a:rPr>
+              <a:t>INPASA Agroindustrial S/A  ·  Manutenção &amp; Automação  ·  ref. 02/07/2026</a:t>
             </a:r>
           </a:p>
         </p:txBody>
@@ -4772,7 +4851,7 @@
         </p:nvSpPr>
         <p:spPr>
           <a:xfrm>
-            <a:off x="11155680" y="6446520"/>
+            <a:off x="11155680" y="6419088"/>
             <a:ext cx="822960" cy="320040"/>
           </a:xfrm>
           <a:prstGeom prst="rect">
@@ -4788,11 +4867,11 @@
           <a:p>
             <a:pPr algn="r"/>
             <a:r>
-              <a:rPr sz="900" b="0">
-                <a:solidFill>
-                  <a:srgbClr val="6B7280"/>
-                </a:solidFill>
-                <a:latin typeface="Inter"/>
+              <a:rPr sz="900" b="0" i="0">
+                <a:solidFill>
+                  <a:srgbClr val="6B7885"/>
+                </a:solidFill>
+                <a:latin typeface="Montserrat"/>
               </a:rPr>
               <a:t>2</a:t>
             </a:r>
@@ -4832,7 +4911,7 @@
             <a:avLst/>
           </a:prstGeom>
           <a:solidFill>
-            <a:srgbClr val="0F0F1A"/>
+            <a:srgbClr val="FFFFFF"/>
           </a:solidFill>
           <a:ln>
             <a:noFill/>
@@ -4870,13 +4949,13 @@
         <p:spPr>
           <a:xfrm>
             <a:off x="0" y="0"/>
-            <a:ext cx="12191695" cy="1097280"/>
+            <a:ext cx="12191695" cy="1051560"/>
           </a:xfrm>
           <a:prstGeom prst="rect">
             <a:avLst/>
           </a:prstGeom>
           <a:solidFill>
-            <a:srgbClr val="1E1E30"/>
+            <a:srgbClr val="124E81"/>
           </a:solidFill>
           <a:ln>
             <a:noFill/>
@@ -4913,14 +4992,14 @@
         </p:nvSpPr>
         <p:spPr>
           <a:xfrm>
-            <a:off x="0" y="1097280"/>
-            <a:ext cx="12191695" cy="36576"/>
+            <a:off x="0" y="1051560"/>
+            <a:ext cx="12191695" cy="45720"/>
           </a:xfrm>
           <a:prstGeom prst="rect">
             <a:avLst/>
           </a:prstGeom>
           <a:solidFill>
-            <a:srgbClr val="F97316"/>
+            <a:srgbClr val="FFA32A"/>
           </a:solidFill>
           <a:ln>
             <a:noFill/>
@@ -4973,11 +5052,11 @@
           <a:p>
             <a:pPr algn="l"/>
             <a:r>
-              <a:rPr sz="1200" b="1">
-                <a:solidFill>
-                  <a:srgbClr val="F97316"/>
-                </a:solidFill>
-                <a:latin typeface="Inter"/>
+              <a:rPr sz="1200" b="1" i="0">
+                <a:solidFill>
+                  <a:srgbClr val="EAA239"/>
+                </a:solidFill>
+                <a:latin typeface="Montserrat"/>
               </a:rPr>
               <a:t>LINHA DO TEMPO</a:t>
             </a:r>
@@ -4992,8 +5071,8 @@
         </p:nvSpPr>
         <p:spPr>
           <a:xfrm>
-            <a:off x="502920" y="420624"/>
-            <a:ext cx="11155680" cy="548640"/>
+            <a:off x="502920" y="402336"/>
+            <a:ext cx="11155680" cy="566928"/>
           </a:xfrm>
           <a:prstGeom prst="rect">
             <a:avLst/>
@@ -5008,11 +5087,11 @@
           <a:p>
             <a:pPr algn="l"/>
             <a:r>
-              <a:rPr sz="2500" b="1">
+              <a:rPr sz="2500" b="1" i="0">
                 <a:solidFill>
                   <a:srgbClr val="FFFFFF"/>
                 </a:solidFill>
-                <a:latin typeface="Inter"/>
+                <a:latin typeface="Montserrat"/>
               </a:rPr>
               <a:t>Marcos de conclusão (jul → dez/2026)</a:t>
             </a:r>
@@ -5034,7 +5113,7 @@
             <a:avLst/>
           </a:prstGeom>
           <a:solidFill>
-            <a:srgbClr val="2A2A40"/>
+            <a:srgbClr val="BDBFC1"/>
           </a:solidFill>
           <a:ln>
             <a:noFill/>
@@ -5087,11 +5166,11 @@
           <a:p>
             <a:pPr algn="l"/>
             <a:r>
-              <a:rPr sz="1200" b="1">
-                <a:solidFill>
-                  <a:srgbClr val="F97316"/>
-                </a:solidFill>
-                <a:latin typeface="Inter"/>
+              <a:rPr sz="1200" b="1" i="0">
+                <a:solidFill>
+                  <a:srgbClr val="124E81"/>
+                </a:solidFill>
+                <a:latin typeface="Montserrat"/>
               </a:rPr>
               <a:t>Jul</a:t>
             </a:r>
@@ -5113,7 +5192,7 @@
             <a:avLst/>
           </a:prstGeom>
           <a:solidFill>
-            <a:srgbClr val="2A2A40"/>
+            <a:srgbClr val="BDBFC1"/>
           </a:solidFill>
           <a:ln>
             <a:noFill/>
@@ -5166,11 +5245,11 @@
           <a:p>
             <a:pPr algn="l"/>
             <a:r>
-              <a:rPr sz="1200" b="1">
-                <a:solidFill>
-                  <a:srgbClr val="F97316"/>
-                </a:solidFill>
-                <a:latin typeface="Inter"/>
+              <a:rPr sz="1200" b="1" i="0">
+                <a:solidFill>
+                  <a:srgbClr val="124E81"/>
+                </a:solidFill>
+                <a:latin typeface="Montserrat"/>
               </a:rPr>
               <a:t>Ago</a:t>
             </a:r>
@@ -5192,7 +5271,7 @@
             <a:avLst/>
           </a:prstGeom>
           <a:solidFill>
-            <a:srgbClr val="2A2A40"/>
+            <a:srgbClr val="BDBFC1"/>
           </a:solidFill>
           <a:ln>
             <a:noFill/>
@@ -5245,11 +5324,11 @@
           <a:p>
             <a:pPr algn="l"/>
             <a:r>
-              <a:rPr sz="1200" b="1">
-                <a:solidFill>
-                  <a:srgbClr val="F97316"/>
-                </a:solidFill>
-                <a:latin typeface="Inter"/>
+              <a:rPr sz="1200" b="1" i="0">
+                <a:solidFill>
+                  <a:srgbClr val="124E81"/>
+                </a:solidFill>
+                <a:latin typeface="Montserrat"/>
               </a:rPr>
               <a:t>Set</a:t>
             </a:r>
@@ -5271,7 +5350,7 @@
             <a:avLst/>
           </a:prstGeom>
           <a:solidFill>
-            <a:srgbClr val="2A2A40"/>
+            <a:srgbClr val="BDBFC1"/>
           </a:solidFill>
           <a:ln>
             <a:noFill/>
@@ -5324,11 +5403,11 @@
           <a:p>
             <a:pPr algn="l"/>
             <a:r>
-              <a:rPr sz="1200" b="1">
-                <a:solidFill>
-                  <a:srgbClr val="F97316"/>
-                </a:solidFill>
-                <a:latin typeface="Inter"/>
+              <a:rPr sz="1200" b="1" i="0">
+                <a:solidFill>
+                  <a:srgbClr val="124E81"/>
+                </a:solidFill>
+                <a:latin typeface="Montserrat"/>
               </a:rPr>
               <a:t>Out</a:t>
             </a:r>
@@ -5350,7 +5429,7 @@
             <a:avLst/>
           </a:prstGeom>
           <a:solidFill>
-            <a:srgbClr val="2A2A40"/>
+            <a:srgbClr val="BDBFC1"/>
           </a:solidFill>
           <a:ln>
             <a:noFill/>
@@ -5403,11 +5482,11 @@
           <a:p>
             <a:pPr algn="l"/>
             <a:r>
-              <a:rPr sz="1200" b="1">
-                <a:solidFill>
-                  <a:srgbClr val="F97316"/>
-                </a:solidFill>
-                <a:latin typeface="Inter"/>
+              <a:rPr sz="1200" b="1" i="0">
+                <a:solidFill>
+                  <a:srgbClr val="124E81"/>
+                </a:solidFill>
+                <a:latin typeface="Montserrat"/>
               </a:rPr>
               <a:t>Nov</a:t>
             </a:r>
@@ -5429,7 +5508,7 @@
             <a:avLst/>
           </a:prstGeom>
           <a:solidFill>
-            <a:srgbClr val="2A2A40"/>
+            <a:srgbClr val="BDBFC1"/>
           </a:solidFill>
           <a:ln>
             <a:noFill/>
@@ -5482,11 +5561,11 @@
           <a:p>
             <a:pPr algn="l"/>
             <a:r>
-              <a:rPr sz="1200" b="1">
-                <a:solidFill>
-                  <a:srgbClr val="F97316"/>
-                </a:solidFill>
-                <a:latin typeface="Inter"/>
+              <a:rPr sz="1200" b="1" i="0">
+                <a:solidFill>
+                  <a:srgbClr val="124E81"/>
+                </a:solidFill>
+                <a:latin typeface="Montserrat"/>
               </a:rPr>
               <a:t>Dez</a:t>
             </a:r>
@@ -5508,7 +5587,7 @@
             <a:avLst/>
           </a:prstGeom>
           <a:solidFill>
-            <a:srgbClr val="EF4444"/>
+            <a:srgbClr val="CC5121"/>
           </a:solidFill>
           <a:ln>
             <a:noFill/>
@@ -5561,11 +5640,11 @@
           <a:p>
             <a:pPr algn="l"/>
             <a:r>
-              <a:rPr sz="1000" b="1">
-                <a:solidFill>
-                  <a:srgbClr val="EF4444"/>
-                </a:solidFill>
-                <a:latin typeface="Inter"/>
+              <a:rPr sz="1000" b="1" i="0">
+                <a:solidFill>
+                  <a:srgbClr val="CC5121"/>
+                </a:solidFill>
+                <a:latin typeface="Montserrat"/>
               </a:rPr>
               <a:t>HOJE</a:t>
             </a:r>
@@ -5596,23 +5675,23 @@
           <a:p>
             <a:pPr algn="l"/>
             <a:r>
-              <a:rPr sz="1100" b="1">
-                <a:solidFill>
-                  <a:srgbClr val="3B82F6"/>
-                </a:solidFill>
-                <a:latin typeface="Inter"/>
-              </a:rPr>
-              <a:t>NVM · Nova Mutum</a:t>
+              <a:rPr sz="1100" b="1" i="0">
+                <a:solidFill>
+                  <a:srgbClr val="124E81"/>
+                </a:solidFill>
+                <a:latin typeface="Montserrat"/>
+              </a:rPr>
+              <a:t>NMT · Nova Mutum</a:t>
             </a:r>
           </a:p>
           <a:p>
             <a:pPr algn="l"/>
             <a:r>
-              <a:rPr sz="1100" b="1">
-                <a:solidFill>
-                  <a:srgbClr val="3B82F6"/>
-                </a:solidFill>
-                <a:latin typeface="Inter"/>
+              <a:rPr sz="1100" b="1" i="0">
+                <a:solidFill>
+                  <a:srgbClr val="124E81"/>
+                </a:solidFill>
+                <a:latin typeface="Montserrat"/>
               </a:rPr>
               <a:t>16 correias</a:t>
             </a:r>
@@ -5634,7 +5713,7 @@
             <a:avLst/>
           </a:prstGeom>
           <a:solidFill>
-            <a:srgbClr val="3B82F6"/>
+            <a:srgbClr val="124E81"/>
           </a:solidFill>
           <a:ln>
             <a:noFill/>
@@ -5687,11 +5766,11 @@
           <a:p>
             <a:pPr algn="l"/>
             <a:r>
-              <a:rPr sz="1100" b="1">
-                <a:solidFill>
-                  <a:srgbClr val="FFFFFF"/>
-                </a:solidFill>
-                <a:latin typeface="Inter"/>
+              <a:rPr sz="1100" b="1" i="0">
+                <a:solidFill>
+                  <a:srgbClr val="20303F"/>
+                </a:solidFill>
+                <a:latin typeface="Montserrat"/>
               </a:rPr>
               <a:t>22/10/2026</a:t>
             </a:r>
@@ -5722,11 +5801,11 @@
           <a:p>
             <a:pPr algn="l"/>
             <a:r>
-              <a:rPr sz="1100" b="1">
-                <a:solidFill>
-                  <a:srgbClr val="F97316"/>
-                </a:solidFill>
-                <a:latin typeface="Inter"/>
+              <a:rPr sz="1100" b="1" i="0">
+                <a:solidFill>
+                  <a:srgbClr val="EAA239"/>
+                </a:solidFill>
+                <a:latin typeface="Montserrat"/>
               </a:rPr>
               <a:t>SNP · Sinop</a:t>
             </a:r>
@@ -5734,11 +5813,11 @@
           <a:p>
             <a:pPr algn="l"/>
             <a:r>
-              <a:rPr sz="1100" b="1">
-                <a:solidFill>
-                  <a:srgbClr val="F97316"/>
-                </a:solidFill>
-                <a:latin typeface="Inter"/>
+              <a:rPr sz="1100" b="1" i="0">
+                <a:solidFill>
+                  <a:srgbClr val="EAA239"/>
+                </a:solidFill>
+                <a:latin typeface="Montserrat"/>
               </a:rPr>
               <a:t>23 correias</a:t>
             </a:r>
@@ -5760,7 +5839,7 @@
             <a:avLst/>
           </a:prstGeom>
           <a:solidFill>
-            <a:srgbClr val="F97316"/>
+            <a:srgbClr val="EAA239"/>
           </a:solidFill>
           <a:ln>
             <a:noFill/>
@@ -5813,11 +5892,11 @@
           <a:p>
             <a:pPr algn="l"/>
             <a:r>
-              <a:rPr sz="1100" b="1">
-                <a:solidFill>
-                  <a:srgbClr val="FFFFFF"/>
-                </a:solidFill>
-                <a:latin typeface="Inter"/>
+              <a:rPr sz="1100" b="1" i="0">
+                <a:solidFill>
+                  <a:srgbClr val="20303F"/>
+                </a:solidFill>
+                <a:latin typeface="Montserrat"/>
               </a:rPr>
               <a:t>30/12/2026</a:t>
             </a:r>
@@ -5848,23 +5927,23 @@
           <a:p>
             <a:pPr algn="l"/>
             <a:r>
-              <a:rPr sz="1100" b="1">
-                <a:solidFill>
-                  <a:srgbClr val="22C55E"/>
-                </a:solidFill>
-                <a:latin typeface="Inter"/>
-              </a:rPr>
-              <a:t>SDL · Sidrolândia</a:t>
+              <a:rPr sz="1100" b="1" i="0">
+                <a:solidFill>
+                  <a:srgbClr val="007D77"/>
+                </a:solidFill>
+                <a:latin typeface="Montserrat"/>
+              </a:rPr>
+              <a:t>SDR · Sidrolândia</a:t>
             </a:r>
           </a:p>
           <a:p>
             <a:pPr algn="l"/>
             <a:r>
-              <a:rPr sz="1100" b="1">
-                <a:solidFill>
-                  <a:srgbClr val="22C55E"/>
-                </a:solidFill>
-                <a:latin typeface="Inter"/>
+              <a:rPr sz="1100" b="1" i="0">
+                <a:solidFill>
+                  <a:srgbClr val="007D77"/>
+                </a:solidFill>
+                <a:latin typeface="Montserrat"/>
               </a:rPr>
               <a:t>2 correias</a:t>
             </a:r>
@@ -5886,7 +5965,7 @@
             <a:avLst/>
           </a:prstGeom>
           <a:solidFill>
-            <a:srgbClr val="22C55E"/>
+            <a:srgbClr val="007D77"/>
           </a:solidFill>
           <a:ln>
             <a:noFill/>
@@ -5939,11 +6018,11 @@
           <a:p>
             <a:pPr algn="l"/>
             <a:r>
-              <a:rPr sz="1100" b="1">
-                <a:solidFill>
-                  <a:srgbClr val="FFFFFF"/>
-                </a:solidFill>
-                <a:latin typeface="Inter"/>
+              <a:rPr sz="1100" b="1" i="0">
+                <a:solidFill>
+                  <a:srgbClr val="20303F"/>
+                </a:solidFill>
+                <a:latin typeface="Montserrat"/>
               </a:rPr>
               <a:t>30/09/2026</a:t>
             </a:r>
@@ -5974,11 +6053,11 @@
           <a:p>
             <a:pPr algn="l"/>
             <a:r>
-              <a:rPr sz="1100" b="1">
-                <a:solidFill>
-                  <a:srgbClr val="A855F7"/>
-                </a:solidFill>
-                <a:latin typeface="Inter"/>
+              <a:rPr sz="1100" b="1" i="0">
+                <a:solidFill>
+                  <a:srgbClr val="007CC5"/>
+                </a:solidFill>
+                <a:latin typeface="Montserrat"/>
               </a:rPr>
               <a:t>BLS · Balsas</a:t>
             </a:r>
@@ -5986,11 +6065,11 @@
           <a:p>
             <a:pPr algn="l"/>
             <a:r>
-              <a:rPr sz="1100" b="1">
-                <a:solidFill>
-                  <a:srgbClr val="A855F7"/>
-                </a:solidFill>
-                <a:latin typeface="Inter"/>
+              <a:rPr sz="1100" b="1" i="0">
+                <a:solidFill>
+                  <a:srgbClr val="007CC5"/>
+                </a:solidFill>
+                <a:latin typeface="Montserrat"/>
               </a:rPr>
               <a:t>5 correias</a:t>
             </a:r>
@@ -6012,7 +6091,7 @@
             <a:avLst/>
           </a:prstGeom>
           <a:solidFill>
-            <a:srgbClr val="A855F7"/>
+            <a:srgbClr val="007CC5"/>
           </a:solidFill>
           <a:ln>
             <a:noFill/>
@@ -6065,11 +6144,11 @@
           <a:p>
             <a:pPr algn="l"/>
             <a:r>
-              <a:rPr sz="1100" b="1">
-                <a:solidFill>
-                  <a:srgbClr val="FFFFFF"/>
-                </a:solidFill>
-                <a:latin typeface="Inter"/>
+              <a:rPr sz="1100" b="1" i="0">
+                <a:solidFill>
+                  <a:srgbClr val="20303F"/>
+                </a:solidFill>
+                <a:latin typeface="Montserrat"/>
               </a:rPr>
               <a:t>24/07/2026</a:t>
             </a:r>
@@ -6100,11 +6179,11 @@
           <a:p>
             <a:pPr algn="l"/>
             <a:r>
-              <a:rPr sz="1300" b="1">
-                <a:solidFill>
-                  <a:srgbClr val="F97316"/>
-                </a:solidFill>
-                <a:latin typeface="Inter"/>
+              <a:rPr sz="1300" b="1" i="0">
+                <a:solidFill>
+                  <a:srgbClr val="124E81"/>
+                </a:solidFill>
+                <a:latin typeface="Montserrat"/>
               </a:rPr>
               <a:t>Conclusão de todo o programa: 30/12/2026 (última — Sinop, esteiras de cavacos da biomassa).</a:t>
             </a:r>
@@ -6119,8 +6198,8 @@
         </p:nvSpPr>
         <p:spPr>
           <a:xfrm>
-            <a:off x="502920" y="6446520"/>
-            <a:ext cx="8229600" cy="320040"/>
+            <a:off x="502920" y="6419088"/>
+            <a:ext cx="9144000" cy="320040"/>
           </a:xfrm>
           <a:prstGeom prst="rect">
             <a:avLst/>
@@ -6135,13 +6214,13 @@
           <a:p>
             <a:pPr algn="l"/>
             <a:r>
-              <a:rPr sz="900" b="0">
-                <a:solidFill>
-                  <a:srgbClr val="6B7280"/>
-                </a:solidFill>
-                <a:latin typeface="Inter"/>
-              </a:rPr>
-              <a:t>INPASA  •  Plano de Substituição de Correias Transportadoras  •  ref. 02/07/2026</a:t>
+              <a:rPr sz="900" b="0" i="0">
+                <a:solidFill>
+                  <a:srgbClr val="6B7885"/>
+                </a:solidFill>
+                <a:latin typeface="Montserrat"/>
+              </a:rPr>
+              <a:t>INPASA Agroindustrial S/A  ·  Manutenção &amp; Automação  ·  ref. 02/07/2026</a:t>
             </a:r>
           </a:p>
         </p:txBody>
@@ -6154,7 +6233,7 @@
         </p:nvSpPr>
         <p:spPr>
           <a:xfrm>
-            <a:off x="11155680" y="6446520"/>
+            <a:off x="11155680" y="6419088"/>
             <a:ext cx="822960" cy="320040"/>
           </a:xfrm>
           <a:prstGeom prst="rect">
@@ -6170,11 +6249,11 @@
           <a:p>
             <a:pPr algn="r"/>
             <a:r>
-              <a:rPr sz="900" b="0">
-                <a:solidFill>
-                  <a:srgbClr val="6B7280"/>
-                </a:solidFill>
-                <a:latin typeface="Inter"/>
+              <a:rPr sz="900" b="0" i="0">
+                <a:solidFill>
+                  <a:srgbClr val="6B7885"/>
+                </a:solidFill>
+                <a:latin typeface="Montserrat"/>
               </a:rPr>
               <a:t>3</a:t>
             </a:r>
@@ -6214,7 +6293,7 @@
             <a:avLst/>
           </a:prstGeom>
           <a:solidFill>
-            <a:srgbClr val="0F0F1A"/>
+            <a:srgbClr val="FFFFFF"/>
           </a:solidFill>
           <a:ln>
             <a:noFill/>
@@ -6252,13 +6331,13 @@
         <p:spPr>
           <a:xfrm>
             <a:off x="0" y="0"/>
-            <a:ext cx="12191695" cy="1097280"/>
+            <a:ext cx="12191695" cy="1051560"/>
           </a:xfrm>
           <a:prstGeom prst="rect">
             <a:avLst/>
           </a:prstGeom>
           <a:solidFill>
-            <a:srgbClr val="1E1E30"/>
+            <a:srgbClr val="124E81"/>
           </a:solidFill>
           <a:ln>
             <a:noFill/>
@@ -6295,14 +6374,14 @@
         </p:nvSpPr>
         <p:spPr>
           <a:xfrm>
-            <a:off x="0" y="1097280"/>
-            <a:ext cx="12191695" cy="36576"/>
+            <a:off x="0" y="1051560"/>
+            <a:ext cx="12191695" cy="45720"/>
           </a:xfrm>
           <a:prstGeom prst="rect">
             <a:avLst/>
           </a:prstGeom>
           <a:solidFill>
-            <a:srgbClr val="F97316"/>
+            <a:srgbClr val="FFA32A"/>
           </a:solidFill>
           <a:ln>
             <a:noFill/>
@@ -6355,11 +6434,11 @@
           <a:p>
             <a:pPr algn="l"/>
             <a:r>
-              <a:rPr sz="1200" b="1">
-                <a:solidFill>
-                  <a:srgbClr val="F97316"/>
-                </a:solidFill>
-                <a:latin typeface="Inter"/>
+              <a:rPr sz="1200" b="1" i="0">
+                <a:solidFill>
+                  <a:srgbClr val="EAA239"/>
+                </a:solidFill>
+                <a:latin typeface="Montserrat"/>
               </a:rPr>
               <a:t>CONSISTÊNCIA DOS NÚMEROS</a:t>
             </a:r>
@@ -6374,8 +6453,8 @@
         </p:nvSpPr>
         <p:spPr>
           <a:xfrm>
-            <a:off x="502920" y="420624"/>
-            <a:ext cx="11155680" cy="548640"/>
+            <a:off x="502920" y="402336"/>
+            <a:ext cx="11155680" cy="566928"/>
           </a:xfrm>
           <a:prstGeom prst="rect">
             <a:avLst/>
@@ -6390,11 +6469,11 @@
           <a:p>
             <a:pPr algn="l"/>
             <a:r>
-              <a:rPr sz="2500" b="1">
+              <a:rPr sz="2500" b="1" i="0">
                 <a:solidFill>
                   <a:srgbClr val="FFFFFF"/>
                 </a:solidFill>
-                <a:latin typeface="Inter"/>
+                <a:latin typeface="Montserrat"/>
               </a:rPr>
               <a:t>Reconciliação: levantamento × execução</a:t>
             </a:r>
@@ -6410,13 +6489,13 @@
         <p:spPr>
           <a:xfrm>
             <a:off x="502920" y="1417320"/>
-            <a:ext cx="5486400" cy="4480560"/>
+            <a:ext cx="5486400" cy="4343400"/>
           </a:xfrm>
           <a:prstGeom prst="roundRect">
             <a:avLst/>
           </a:prstGeom>
           <a:solidFill>
-            <a:srgbClr val="1E1E30"/>
+            <a:srgbClr val="F2F5F8"/>
           </a:solidFill>
           <a:ln>
             <a:noFill/>
@@ -6469,11 +6548,11 @@
           <a:p>
             <a:pPr algn="l"/>
             <a:r>
-              <a:rPr sz="1500" b="1">
-                <a:solidFill>
-                  <a:srgbClr val="F97316"/>
-                </a:solidFill>
-                <a:latin typeface="Inter"/>
+              <a:rPr sz="1500" b="1" i="0">
+                <a:solidFill>
+                  <a:srgbClr val="124E81"/>
+                </a:solidFill>
+                <a:latin typeface="Montserrat"/>
               </a:rPr>
               <a:t>Levantamento FLEXLAB (jun/2026)</a:t>
             </a:r>
@@ -6489,7 +6568,7 @@
         <p:spPr>
           <a:xfrm>
             <a:off x="777240" y="2148840"/>
-            <a:ext cx="5029200" cy="640080"/>
+            <a:ext cx="5029200" cy="603504"/>
           </a:xfrm>
           <a:prstGeom prst="rect">
             <a:avLst/>
@@ -6504,11 +6583,11 @@
           <a:p>
             <a:pPr algn="l"/>
             <a:r>
-              <a:rPr sz="1300" b="0">
-                <a:solidFill>
-                  <a:srgbClr val="FFFFFF"/>
-                </a:solidFill>
-                <a:latin typeface="Inter"/>
+              <a:rPr sz="1300" b="0" i="0">
+                <a:solidFill>
+                  <a:srgbClr val="20303F"/>
+                </a:solidFill>
+                <a:latin typeface="Montserrat"/>
               </a:rPr>
               <a:t>•  148 correias auditadas no grupo</a:t>
             </a:r>
@@ -6523,8 +6602,8 @@
         </p:nvSpPr>
         <p:spPr>
           <a:xfrm>
-            <a:off x="777240" y="2807208"/>
-            <a:ext cx="5029200" cy="640080"/>
+            <a:off x="777240" y="2770632"/>
+            <a:ext cx="5029200" cy="603504"/>
           </a:xfrm>
           <a:prstGeom prst="rect">
             <a:avLst/>
@@ -6539,13 +6618,13 @@
           <a:p>
             <a:pPr algn="l"/>
             <a:r>
-              <a:rPr sz="1300" b="0">
-                <a:solidFill>
-                  <a:srgbClr val="9CA3AF"/>
-                </a:solidFill>
-                <a:latin typeface="Inter"/>
-              </a:rPr>
-              <a:t>102 mantidas em operação (conforme norma / 2ª linha)</a:t>
+              <a:rPr sz="1300" b="0" i="0">
+                <a:solidFill>
+                  <a:srgbClr val="6B7885"/>
+                </a:solidFill>
+                <a:latin typeface="Montserrat"/>
+              </a:rPr>
+              <a:t>102 mantidas em operação</a:t>
             </a:r>
           </a:p>
         </p:txBody>
@@ -6558,8 +6637,8 @@
         </p:nvSpPr>
         <p:spPr>
           <a:xfrm>
-            <a:off x="777240" y="3465576"/>
-            <a:ext cx="5029200" cy="640080"/>
+            <a:off x="777240" y="3392424"/>
+            <a:ext cx="5029200" cy="603504"/>
           </a:xfrm>
           <a:prstGeom prst="rect">
             <a:avLst/>
@@ -6574,11 +6653,11 @@
           <a:p>
             <a:pPr algn="l"/>
             <a:r>
-              <a:rPr sz="1300" b="1">
-                <a:solidFill>
-                  <a:srgbClr val="FFFFFF"/>
-                </a:solidFill>
-                <a:latin typeface="Inter"/>
+              <a:rPr sz="1300" b="1" i="0">
+                <a:solidFill>
+                  <a:srgbClr val="20303F"/>
+                </a:solidFill>
+                <a:latin typeface="Montserrat"/>
               </a:rPr>
               <a:t>•  46 a substituir  →  R$ 6,15 mi</a:t>
             </a:r>
@@ -6593,8 +6672,8 @@
         </p:nvSpPr>
         <p:spPr>
           <a:xfrm>
-            <a:off x="777240" y="4123944"/>
-            <a:ext cx="5029200" cy="640080"/>
+            <a:off x="777240" y="4014216"/>
+            <a:ext cx="5029200" cy="603504"/>
           </a:xfrm>
           <a:prstGeom prst="rect">
             <a:avLst/>
@@ -6609,13 +6688,13 @@
           <a:p>
             <a:pPr algn="l"/>
             <a:r>
-              <a:rPr sz="1300" b="0">
-                <a:solidFill>
-                  <a:srgbClr val="9CA3AF"/>
-                </a:solidFill>
-                <a:latin typeface="Inter"/>
-              </a:rPr>
-              <a:t>   • 41 reprovadas no ensaio ISO 340 (imediata)</a:t>
+              <a:rPr sz="1300" b="0" i="0">
+                <a:solidFill>
+                  <a:srgbClr val="6B7885"/>
+                </a:solidFill>
+                <a:latin typeface="Montserrat"/>
+              </a:rPr>
+              <a:t>   • 41 reprovadas no ensaio ISO 340</a:t>
             </a:r>
           </a:p>
         </p:txBody>
@@ -6628,8 +6707,8 @@
         </p:nvSpPr>
         <p:spPr>
           <a:xfrm>
-            <a:off x="777240" y="4782312"/>
-            <a:ext cx="5029200" cy="640080"/>
+            <a:off x="777240" y="4636008"/>
+            <a:ext cx="5029200" cy="603504"/>
           </a:xfrm>
           <a:prstGeom prst="rect">
             <a:avLst/>
@@ -6644,13 +6723,13 @@
           <a:p>
             <a:pPr algn="l"/>
             <a:r>
-              <a:rPr sz="1300" b="0">
-                <a:solidFill>
-                  <a:srgbClr val="9CA3AF"/>
-                </a:solidFill>
-                <a:latin typeface="Inter"/>
-              </a:rPr>
-              <a:t>   • 5 por degradação física (programada)</a:t>
+              <a:rPr sz="1300" b="0" i="0">
+                <a:solidFill>
+                  <a:srgbClr val="6B7885"/>
+                </a:solidFill>
+                <a:latin typeface="Montserrat"/>
+              </a:rPr>
+              <a:t>   • 5 por degradação física</a:t>
             </a:r>
           </a:p>
         </p:txBody>
@@ -6664,13 +6743,13 @@
         <p:spPr>
           <a:xfrm>
             <a:off x="6217920" y="1417320"/>
-            <a:ext cx="5486400" cy="4480560"/>
+            <a:ext cx="5486400" cy="4343400"/>
           </a:xfrm>
           <a:prstGeom prst="roundRect">
             <a:avLst/>
           </a:prstGeom>
           <a:solidFill>
-            <a:srgbClr val="1E1E30"/>
+            <a:srgbClr val="F2F5F8"/>
           </a:solidFill>
           <a:ln>
             <a:noFill/>
@@ -6723,11 +6802,11 @@
           <a:p>
             <a:pPr algn="l"/>
             <a:r>
-              <a:rPr sz="1500" b="1">
-                <a:solidFill>
-                  <a:srgbClr val="22C55E"/>
-                </a:solidFill>
-                <a:latin typeface="Inter"/>
+              <a:rPr sz="1500" b="1" i="0">
+                <a:solidFill>
+                  <a:srgbClr val="609346"/>
+                </a:solidFill>
+                <a:latin typeface="Montserrat"/>
               </a:rPr>
               <a:t>Plano de execução (dashboard atual)</a:t>
             </a:r>
@@ -6743,7 +6822,7 @@
         <p:spPr>
           <a:xfrm>
             <a:off x="6492240" y="2148840"/>
-            <a:ext cx="5029200" cy="640080"/>
+            <a:ext cx="5029200" cy="603504"/>
           </a:xfrm>
           <a:prstGeom prst="rect">
             <a:avLst/>
@@ -6758,11 +6837,11 @@
           <a:p>
             <a:pPr algn="l"/>
             <a:r>
-              <a:rPr sz="1300" b="1">
-                <a:solidFill>
-                  <a:srgbClr val="FFFFFF"/>
-                </a:solidFill>
-                <a:latin typeface="Inter"/>
+              <a:rPr sz="1300" b="1" i="0">
+                <a:solidFill>
+                  <a:srgbClr val="20303F"/>
+                </a:solidFill>
+                <a:latin typeface="Montserrat"/>
               </a:rPr>
               <a:t>•  46 correias no plano  ✓ bate com as 46</a:t>
             </a:r>
@@ -6777,8 +6856,8 @@
         </p:nvSpPr>
         <p:spPr>
           <a:xfrm>
-            <a:off x="6492240" y="2807208"/>
-            <a:ext cx="5029200" cy="640080"/>
+            <a:off x="6492240" y="2770632"/>
+            <a:ext cx="5029200" cy="603504"/>
           </a:xfrm>
           <a:prstGeom prst="rect">
             <a:avLst/>
@@ -6793,11 +6872,11 @@
           <a:p>
             <a:pPr algn="l"/>
             <a:r>
-              <a:rPr sz="1300" b="0">
-                <a:solidFill>
-                  <a:srgbClr val="9CA3AF"/>
-                </a:solidFill>
-                <a:latin typeface="Inter"/>
+              <a:rPr sz="1300" b="0" i="0">
+                <a:solidFill>
+                  <a:srgbClr val="6B7885"/>
+                </a:solidFill>
+                <a:latin typeface="Montserrat"/>
               </a:rPr>
               <a:t>   • 3 já concluídas</a:t>
             </a:r>
@@ -6812,8 +6891,8 @@
         </p:nvSpPr>
         <p:spPr>
           <a:xfrm>
-            <a:off x="6492240" y="3465576"/>
-            <a:ext cx="5029200" cy="640080"/>
+            <a:off x="6492240" y="3392424"/>
+            <a:ext cx="5029200" cy="603504"/>
           </a:xfrm>
           <a:prstGeom prst="rect">
             <a:avLst/>
@@ -6828,11 +6907,11 @@
           <a:p>
             <a:pPr algn="l"/>
             <a:r>
-              <a:rPr sz="1300" b="0">
-                <a:solidFill>
-                  <a:srgbClr val="9CA3AF"/>
-                </a:solidFill>
-                <a:latin typeface="Inter"/>
+              <a:rPr sz="1300" b="0" i="0">
+                <a:solidFill>
+                  <a:srgbClr val="6B7885"/>
+                </a:solidFill>
+                <a:latin typeface="Montserrat"/>
               </a:rPr>
               <a:t>   • 43 em execução</a:t>
             </a:r>
@@ -6847,8 +6926,8 @@
         </p:nvSpPr>
         <p:spPr>
           <a:xfrm>
-            <a:off x="6492240" y="4123944"/>
-            <a:ext cx="5029200" cy="640080"/>
+            <a:off x="6492240" y="4014216"/>
+            <a:ext cx="5029200" cy="603504"/>
           </a:xfrm>
           <a:prstGeom prst="rect">
             <a:avLst/>
@@ -6863,11 +6942,11 @@
           <a:p>
             <a:pPr algn="l"/>
             <a:r>
-              <a:rPr sz="1300" b="1">
-                <a:solidFill>
-                  <a:srgbClr val="FFFFFF"/>
-                </a:solidFill>
-                <a:latin typeface="Inter"/>
+              <a:rPr sz="1300" b="1" i="0">
+                <a:solidFill>
+                  <a:srgbClr val="20303F"/>
+                </a:solidFill>
+                <a:latin typeface="Montserrat"/>
               </a:rPr>
               <a:t>•  Conclusão: 30/12/2026</a:t>
             </a:r>
@@ -6882,8 +6961,8 @@
         </p:nvSpPr>
         <p:spPr>
           <a:xfrm>
-            <a:off x="6492240" y="4782312"/>
-            <a:ext cx="5029200" cy="640080"/>
+            <a:off x="6492240" y="4636008"/>
+            <a:ext cx="5029200" cy="603504"/>
           </a:xfrm>
           <a:prstGeom prst="rect">
             <a:avLst/>
@@ -6898,11 +6977,11 @@
           <a:p>
             <a:pPr algn="l"/>
             <a:r>
-              <a:rPr sz="1300" b="0">
-                <a:solidFill>
-                  <a:srgbClr val="9CA3AF"/>
-                </a:solidFill>
-                <a:latin typeface="Inter"/>
+              <a:rPr sz="1300" b="0" i="0">
+                <a:solidFill>
+                  <a:srgbClr val="6B7885"/>
+                </a:solidFill>
+                <a:latin typeface="Montserrat"/>
               </a:rPr>
               <a:t>0 correias vencidas</a:t>
             </a:r>
@@ -6917,7 +6996,7 @@
         </p:nvSpPr>
         <p:spPr>
           <a:xfrm>
-            <a:off x="502920" y="5989320"/>
+            <a:off x="502920" y="5897880"/>
             <a:ext cx="11247120" cy="457200"/>
           </a:xfrm>
           <a:prstGeom prst="rect">
@@ -6933,13 +7012,13 @@
           <a:p>
             <a:pPr algn="l"/>
             <a:r>
-              <a:rPr sz="1050" b="0">
-                <a:solidFill>
-                  <a:srgbClr val="EAB308"/>
-                </a:solidFill>
-                <a:latin typeface="Inter"/>
-              </a:rPr>
-              <a:t>Obs.: padronizar código NMT/NVM (mesma planta) · confirmar unidades DRD e LEM · 1 dos 46 é sobressalente em estoque (45 esteiras físicas).</a:t>
+              <a:rPr sz="1050" b="0" i="0">
+                <a:solidFill>
+                  <a:srgbClr val="CC5121"/>
+                </a:solidFill>
+                <a:latin typeface="Montserrat"/>
+              </a:rPr>
+              <a:t>Obs.: cadastro do dashboard usa NVM/SDL — padronizar p/ os códigos oficiais NMT e SDR · confirmar unidades DRD e LEM · 1 dos 46 é sobressalente em estoque (45 esteiras físicas).</a:t>
             </a:r>
           </a:p>
         </p:txBody>
@@ -6952,8 +7031,8 @@
         </p:nvSpPr>
         <p:spPr>
           <a:xfrm>
-            <a:off x="502920" y="6446520"/>
-            <a:ext cx="8229600" cy="320040"/>
+            <a:off x="502920" y="6419088"/>
+            <a:ext cx="9144000" cy="320040"/>
           </a:xfrm>
           <a:prstGeom prst="rect">
             <a:avLst/>
@@ -6968,13 +7047,13 @@
           <a:p>
             <a:pPr algn="l"/>
             <a:r>
-              <a:rPr sz="900" b="0">
-                <a:solidFill>
-                  <a:srgbClr val="6B7280"/>
-                </a:solidFill>
-                <a:latin typeface="Inter"/>
-              </a:rPr>
-              <a:t>INPASA  •  Plano de Substituição de Correias Transportadoras  •  ref. 02/07/2026</a:t>
+              <a:rPr sz="900" b="0" i="0">
+                <a:solidFill>
+                  <a:srgbClr val="6B7885"/>
+                </a:solidFill>
+                <a:latin typeface="Montserrat"/>
+              </a:rPr>
+              <a:t>INPASA Agroindustrial S/A  ·  Manutenção &amp; Automação  ·  ref. 02/07/2026</a:t>
             </a:r>
           </a:p>
         </p:txBody>
@@ -6987,7 +7066,7 @@
         </p:nvSpPr>
         <p:spPr>
           <a:xfrm>
-            <a:off x="11155680" y="6446520"/>
+            <a:off x="11155680" y="6419088"/>
             <a:ext cx="822960" cy="320040"/>
           </a:xfrm>
           <a:prstGeom prst="rect">
@@ -7003,11 +7082,11 @@
           <a:p>
             <a:pPr algn="r"/>
             <a:r>
-              <a:rPr sz="900" b="0">
-                <a:solidFill>
-                  <a:srgbClr val="6B7280"/>
-                </a:solidFill>
-                <a:latin typeface="Inter"/>
+              <a:rPr sz="900" b="0" i="0">
+                <a:solidFill>
+                  <a:srgbClr val="6B7885"/>
+                </a:solidFill>
+                <a:latin typeface="Montserrat"/>
               </a:rPr>
               <a:t>4</a:t>
             </a:r>
@@ -7047,7 +7126,7 @@
             <a:avLst/>
           </a:prstGeom>
           <a:solidFill>
-            <a:srgbClr val="0F0F1A"/>
+            <a:srgbClr val="FFFFFF"/>
           </a:solidFill>
           <a:ln>
             <a:noFill/>
@@ -7085,13 +7164,13 @@
         <p:spPr>
           <a:xfrm>
             <a:off x="0" y="0"/>
-            <a:ext cx="12191695" cy="1097280"/>
+            <a:ext cx="12191695" cy="1051560"/>
           </a:xfrm>
           <a:prstGeom prst="rect">
             <a:avLst/>
           </a:prstGeom>
           <a:solidFill>
-            <a:srgbClr val="1E1E30"/>
+            <a:srgbClr val="124E81"/>
           </a:solidFill>
           <a:ln>
             <a:noFill/>
@@ -7128,14 +7207,14 @@
         </p:nvSpPr>
         <p:spPr>
           <a:xfrm>
-            <a:off x="0" y="1097280"/>
-            <a:ext cx="12191695" cy="36576"/>
+            <a:off x="0" y="1051560"/>
+            <a:ext cx="12191695" cy="45720"/>
           </a:xfrm>
           <a:prstGeom prst="rect">
             <a:avLst/>
           </a:prstGeom>
           <a:solidFill>
-            <a:srgbClr val="F97316"/>
+            <a:srgbClr val="FFA32A"/>
           </a:solidFill>
           <a:ln>
             <a:noFill/>
@@ -7188,11 +7267,11 @@
           <a:p>
             <a:pPr algn="l"/>
             <a:r>
-              <a:rPr sz="1200" b="1">
-                <a:solidFill>
-                  <a:srgbClr val="F97316"/>
-                </a:solidFill>
-                <a:latin typeface="Inter"/>
+              <a:rPr sz="1200" b="1" i="0">
+                <a:solidFill>
+                  <a:srgbClr val="EAA239"/>
+                </a:solidFill>
+                <a:latin typeface="Montserrat"/>
               </a:rPr>
               <a:t>DECISÃO E AÇÃO</a:t>
             </a:r>
@@ -7207,8 +7286,8 @@
         </p:nvSpPr>
         <p:spPr>
           <a:xfrm>
-            <a:off x="502920" y="420624"/>
-            <a:ext cx="11155680" cy="548640"/>
+            <a:off x="502920" y="402336"/>
+            <a:ext cx="11155680" cy="566928"/>
           </a:xfrm>
           <a:prstGeom prst="rect">
             <a:avLst/>
@@ -7223,11 +7302,11 @@
           <a:p>
             <a:pPr algn="l"/>
             <a:r>
-              <a:rPr sz="2500" b="1">
+              <a:rPr sz="2500" b="1" i="0">
                 <a:solidFill>
                   <a:srgbClr val="FFFFFF"/>
                 </a:solidFill>
-                <a:latin typeface="Inter"/>
+                <a:latin typeface="Montserrat"/>
               </a:rPr>
               <a:t>Cuidado especial até concluir a substituição</a:t>
             </a:r>
@@ -7243,13 +7322,13 @@
         <p:spPr>
           <a:xfrm>
             <a:off x="502920" y="1417320"/>
-            <a:ext cx="5486400" cy="4480560"/>
+            <a:ext cx="5486400" cy="4343400"/>
           </a:xfrm>
           <a:prstGeom prst="roundRect">
             <a:avLst/>
           </a:prstGeom>
           <a:solidFill>
-            <a:srgbClr val="1E1E30"/>
+            <a:srgbClr val="F2F5F8"/>
           </a:solidFill>
           <a:ln>
             <a:noFill/>
@@ -7302,13 +7381,13 @@
           <a:p>
             <a:pPr algn="l"/>
             <a:r>
-              <a:rPr sz="1600" b="1">
-                <a:solidFill>
-                  <a:srgbClr val="EF4444"/>
-                </a:solidFill>
-                <a:latin typeface="Inter"/>
-              </a:rPr>
-              <a:t>⚠  Pontos de atenção</a:t>
+              <a:rPr sz="1600" b="1" i="0">
+                <a:solidFill>
+                  <a:srgbClr val="CC5121"/>
+                </a:solidFill>
+                <a:latin typeface="Montserrat"/>
+              </a:rPr>
+              <a:t>Pontos de atenção</a:t>
             </a:r>
           </a:p>
         </p:txBody>
@@ -7322,7 +7401,7 @@
         <p:spPr>
           <a:xfrm>
             <a:off x="777240" y="2148840"/>
-            <a:ext cx="4937760" cy="914400"/>
+            <a:ext cx="4937760" cy="868680"/>
           </a:xfrm>
           <a:prstGeom prst="rect">
             <a:avLst/>
@@ -7341,13 +7420,13 @@
               </a:lnSpc>
             </a:pPr>
             <a:r>
-              <a:rPr sz="1300" b="0">
-                <a:solidFill>
-                  <a:srgbClr val="E0E0E0"/>
-                </a:solidFill>
-                <a:latin typeface="Inter"/>
-              </a:rPr>
-              <a:t>•  7 correias urgentes (&lt;=30 dias) — biomassa (SNP), DDGS (SDL/BLS), julho.</a:t>
+              <a:rPr sz="1300" b="0" i="0">
+                <a:solidFill>
+                  <a:srgbClr val="20303F"/>
+                </a:solidFill>
+                <a:latin typeface="Montserrat"/>
+              </a:rPr>
+              <a:t>•  7 correias urgentes (&lt;=30 dias) — biomassa (SNP), DDGS (SDR/BLS), julho.</a:t>
             </a:r>
           </a:p>
         </p:txBody>
@@ -7360,8 +7439,8 @@
         </p:nvSpPr>
         <p:spPr>
           <a:xfrm>
-            <a:off x="777240" y="3063240"/>
-            <a:ext cx="4937760" cy="914400"/>
+            <a:off x="777240" y="3017520"/>
+            <a:ext cx="4937760" cy="868680"/>
           </a:xfrm>
           <a:prstGeom prst="rect">
             <a:avLst/>
@@ -7380,11 +7459,11 @@
               </a:lnSpc>
             </a:pPr>
             <a:r>
-              <a:rPr sz="1300" b="0">
-                <a:solidFill>
-                  <a:srgbClr val="E0E0E0"/>
-                </a:solidFill>
-                <a:latin typeface="Inter"/>
+              <a:rPr sz="1300" b="0" i="0">
+                <a:solidFill>
+                  <a:srgbClr val="20303F"/>
+                </a:solidFill>
+                <a:latin typeface="Montserrat"/>
               </a:rPr>
               <a:t>•  Conclusão do programa depende da SNP (esteiras de cavacos, 30/12/2026).</a:t>
             </a:r>
@@ -7399,8 +7478,8 @@
         </p:nvSpPr>
         <p:spPr>
           <a:xfrm>
-            <a:off x="777240" y="3977640"/>
-            <a:ext cx="4937760" cy="914400"/>
+            <a:off x="777240" y="3886200"/>
+            <a:ext cx="4937760" cy="868680"/>
           </a:xfrm>
           <a:prstGeom prst="rect">
             <a:avLst/>
@@ -7419,11 +7498,11 @@
               </a:lnSpc>
             </a:pPr>
             <a:r>
-              <a:rPr sz="1300" b="0">
-                <a:solidFill>
-                  <a:srgbClr val="E0E0E0"/>
-                </a:solidFill>
-                <a:latin typeface="Inter"/>
+              <a:rPr sz="1300" b="0" i="0">
+                <a:solidFill>
+                  <a:srgbClr val="20303F"/>
+                </a:solidFill>
+                <a:latin typeface="Montserrat"/>
               </a:rPr>
               <a:t>•  Biomassa e grãos: maior exposição a incêndio por atrito (rolete/correia).</a:t>
             </a:r>
@@ -7438,8 +7517,8 @@
         </p:nvSpPr>
         <p:spPr>
           <a:xfrm>
-            <a:off x="777240" y="4892040"/>
-            <a:ext cx="4937760" cy="914400"/>
+            <a:off x="777240" y="4754880"/>
+            <a:ext cx="4937760" cy="868680"/>
           </a:xfrm>
           <a:prstGeom prst="rect">
             <a:avLst/>
@@ -7458,11 +7537,11 @@
               </a:lnSpc>
             </a:pPr>
             <a:r>
-              <a:rPr sz="1300" b="0">
-                <a:solidFill>
-                  <a:srgbClr val="E0E0E0"/>
-                </a:solidFill>
-                <a:latin typeface="Inter"/>
+              <a:rPr sz="1300" b="0" i="0">
+                <a:solidFill>
+                  <a:srgbClr val="20303F"/>
+                </a:solidFill>
+                <a:latin typeface="Montserrat"/>
               </a:rPr>
               <a:t>•  Janela de transição: risco elevado até a troca de todas as correias.</a:t>
             </a:r>
@@ -7478,13 +7557,13 @@
         <p:spPr>
           <a:xfrm>
             <a:off x="6217920" y="1417320"/>
-            <a:ext cx="5486400" cy="4480560"/>
+            <a:ext cx="5486400" cy="4343400"/>
           </a:xfrm>
           <a:prstGeom prst="roundRect">
             <a:avLst/>
           </a:prstGeom>
           <a:solidFill>
-            <a:srgbClr val="1E1E30"/>
+            <a:srgbClr val="F2F5F8"/>
           </a:solidFill>
           <a:ln>
             <a:noFill/>
@@ -7537,13 +7616,13 @@
           <a:p>
             <a:pPr algn="l"/>
             <a:r>
-              <a:rPr sz="1600" b="1">
-                <a:solidFill>
-                  <a:srgbClr val="22C55E"/>
-                </a:solidFill>
-                <a:latin typeface="Inter"/>
-              </a:rPr>
-              <a:t>✓  Encaminhamentos</a:t>
+              <a:rPr sz="1600" b="1" i="0">
+                <a:solidFill>
+                  <a:srgbClr val="609346"/>
+                </a:solidFill>
+                <a:latin typeface="Montserrat"/>
+              </a:rPr>
+              <a:t>Encaminhamentos</a:t>
             </a:r>
           </a:p>
         </p:txBody>
@@ -7557,7 +7636,7 @@
         <p:spPr>
           <a:xfrm>
             <a:off x="6492240" y="2148840"/>
-            <a:ext cx="4937760" cy="914400"/>
+            <a:ext cx="4937760" cy="868680"/>
           </a:xfrm>
           <a:prstGeom prst="rect">
             <a:avLst/>
@@ -7576,11 +7655,11 @@
               </a:lnSpc>
             </a:pPr>
             <a:r>
-              <a:rPr sz="1300" b="0">
-                <a:solidFill>
-                  <a:srgbClr val="E0E0E0"/>
-                </a:solidFill>
-                <a:latin typeface="Inter"/>
+              <a:rPr sz="1300" b="0" i="0">
+                <a:solidFill>
+                  <a:srgbClr val="20303F"/>
+                </a:solidFill>
+                <a:latin typeface="Montserrat"/>
               </a:rPr>
               <a:t>•  PCM acionado para alinhar com TODAS as áreas cuidado reforçado até concluir a substituição das correias.</a:t>
             </a:r>
@@ -7595,8 +7674,8 @@
         </p:nvSpPr>
         <p:spPr>
           <a:xfrm>
-            <a:off x="6492240" y="3063240"/>
-            <a:ext cx="4937760" cy="914400"/>
+            <a:off x="6492240" y="3017520"/>
+            <a:ext cx="4937760" cy="868680"/>
           </a:xfrm>
           <a:prstGeom prst="rect">
             <a:avLst/>
@@ -7615,11 +7694,11 @@
               </a:lnSpc>
             </a:pPr>
             <a:r>
-              <a:rPr sz="1300" b="0">
-                <a:solidFill>
-                  <a:srgbClr val="E0E0E0"/>
-                </a:solidFill>
-                <a:latin typeface="Inter"/>
+              <a:rPr sz="1300" b="0" i="0">
+                <a:solidFill>
+                  <a:srgbClr val="20303F"/>
+                </a:solidFill>
+                <a:latin typeface="Montserrat"/>
               </a:rPr>
               <a:t>•  Priorizar as correias urgentes de julho (biomassa/DDGS).</a:t>
             </a:r>
@@ -7634,8 +7713,8 @@
         </p:nvSpPr>
         <p:spPr>
           <a:xfrm>
-            <a:off x="6492240" y="3977640"/>
-            <a:ext cx="4937760" cy="914400"/>
+            <a:off x="6492240" y="3886200"/>
+            <a:ext cx="4937760" cy="868680"/>
           </a:xfrm>
           <a:prstGeom prst="rect">
             <a:avLst/>
@@ -7654,11 +7733,11 @@
               </a:lnSpc>
             </a:pPr>
             <a:r>
-              <a:rPr sz="1300" b="0">
-                <a:solidFill>
-                  <a:srgbClr val="E0E0E0"/>
-                </a:solidFill>
-                <a:latin typeface="Inter"/>
+              <a:rPr sz="1300" b="0" i="0">
+                <a:solidFill>
+                  <a:srgbClr val="20303F"/>
+                </a:solidFill>
+                <a:latin typeface="Montserrat"/>
               </a:rPr>
               <a:t>•  Reporte quinzenal de avanço por unidade (concluídas x plano).</a:t>
             </a:r>
@@ -7673,8 +7752,8 @@
         </p:nvSpPr>
         <p:spPr>
           <a:xfrm>
-            <a:off x="6492240" y="4892040"/>
-            <a:ext cx="4937760" cy="914400"/>
+            <a:off x="6492240" y="4754880"/>
+            <a:ext cx="4937760" cy="868680"/>
           </a:xfrm>
           <a:prstGeom prst="rect">
             <a:avLst/>
@@ -7693,13 +7772,13 @@
               </a:lnSpc>
             </a:pPr>
             <a:r>
-              <a:rPr sz="1300" b="0">
-                <a:solidFill>
-                  <a:srgbClr val="E0E0E0"/>
-                </a:solidFill>
-                <a:latin typeface="Inter"/>
-              </a:rPr>
-              <a:t>•  Padronizar cadastro (NMT/NVM) e confirmar DRD/LEM.</a:t>
+              <a:rPr sz="1300" b="0" i="0">
+                <a:solidFill>
+                  <a:srgbClr val="20303F"/>
+                </a:solidFill>
+                <a:latin typeface="Montserrat"/>
+              </a:rPr>
+              <a:t>•  Padronizar cadastro (NVM/SDL → NMT/SDR) e confirmar DRD/LEM.</a:t>
             </a:r>
           </a:p>
         </p:txBody>
@@ -7712,8 +7791,8 @@
         </p:nvSpPr>
         <p:spPr>
           <a:xfrm>
-            <a:off x="502920" y="6446520"/>
-            <a:ext cx="8229600" cy="320040"/>
+            <a:off x="502920" y="6419088"/>
+            <a:ext cx="9144000" cy="320040"/>
           </a:xfrm>
           <a:prstGeom prst="rect">
             <a:avLst/>
@@ -7728,13 +7807,13 @@
           <a:p>
             <a:pPr algn="l"/>
             <a:r>
-              <a:rPr sz="900" b="0">
-                <a:solidFill>
-                  <a:srgbClr val="6B7280"/>
-                </a:solidFill>
-                <a:latin typeface="Inter"/>
-              </a:rPr>
-              <a:t>INPASA  •  Plano de Substituição de Correias Transportadoras  •  ref. 02/07/2026</a:t>
+              <a:rPr sz="900" b="0" i="0">
+                <a:solidFill>
+                  <a:srgbClr val="6B7885"/>
+                </a:solidFill>
+                <a:latin typeface="Montserrat"/>
+              </a:rPr>
+              <a:t>INPASA Agroindustrial S/A  ·  Manutenção &amp; Automação  ·  ref. 02/07/2026</a:t>
             </a:r>
           </a:p>
         </p:txBody>
@@ -7747,7 +7826,7 @@
         </p:nvSpPr>
         <p:spPr>
           <a:xfrm>
-            <a:off x="11155680" y="6446520"/>
+            <a:off x="11155680" y="6419088"/>
             <a:ext cx="822960" cy="320040"/>
           </a:xfrm>
           <a:prstGeom prst="rect">
@@ -7763,11 +7842,11 @@
           <a:p>
             <a:pPr algn="r"/>
             <a:r>
-              <a:rPr sz="900" b="0">
-                <a:solidFill>
-                  <a:srgbClr val="6B7280"/>
-                </a:solidFill>
-                <a:latin typeface="Inter"/>
+              <a:rPr sz="900" b="0" i="0">
+                <a:solidFill>
+                  <a:srgbClr val="6B7885"/>
+                </a:solidFill>
+                <a:latin typeface="Montserrat"/>
               </a:rPr>
               <a:t>5</a:t>
             </a:r>

</xml_diff>

<commit_message>
Incorpora observações: valor só material e escopo de unidades
- Esclarece que R$ 6,15 mi são apenas as correias (material);
  montagem com mão de obra interna, apenas vulcanização externa.
- Registra que Dourados (DRD) e LEM ficam fora por não terem
  pendências (escopo), não por omissão.

Co-Authored-By: Claude Opus 4.8 <noreply@anthropic.com>
Claude-Session: https://claude.ai/code/session_01JAKYhBZ2VtJTfAk2iunizq
</commit_message>
<xml_diff>
--- a/plano_seguranca/Apresentacao_Estrategica_Correias_INPASA.pptx
+++ b/plano_seguranca/Apresentacao_Estrategica_Correias_INPASA.pptx
@@ -6659,7 +6659,7 @@
                 </a:solidFill>
                 <a:latin typeface="Montserrat"/>
               </a:rPr>
-              <a:t>•  46 a substituir  →  R$ 6,15 mi</a:t>
+              <a:t>•  46 a substituir  →  R$ 6,15 mi (só correias)</a:t>
             </a:r>
           </a:p>
         </p:txBody>
@@ -6996,8 +6996,8 @@
         </p:nvSpPr>
         <p:spPr>
           <a:xfrm>
-            <a:off x="502920" y="5897880"/>
-            <a:ext cx="11247120" cy="457200"/>
+            <a:off x="502920" y="5806440"/>
+            <a:ext cx="11247120" cy="548640"/>
           </a:xfrm>
           <a:prstGeom prst="rect">
             <a:avLst/>
@@ -7018,7 +7018,7 @@
                 </a:solidFill>
                 <a:latin typeface="Montserrat"/>
               </a:rPr>
-              <a:t>Obs.: cadastro do dashboard usa NVM/SDL — padronizar p/ os códigos oficiais NMT e SDR · confirmar unidades DRD e LEM · 1 dos 46 é sobressalente em estoque (45 esteiras físicas).</a:t>
+              <a:t>Obs.: R$ 6,15 mi = somente as correias (material) — montagem com mão de obra interna, apenas vulcanização externa · Dourados (DRD) e LEM sem pendências (fora do escopo) · cadastro do dashboard usa NVM/SDL → padronizar p/ NMT/SDR · 1 dos 46 é sobressalente em estoque (45 esteiras físicas).</a:t>
             </a:r>
           </a:p>
         </p:txBody>
@@ -7778,7 +7778,7 @@
                 </a:solidFill>
                 <a:latin typeface="Montserrat"/>
               </a:rPr>
-              <a:t>•  Padronizar cadastro (NVM/SDL → NMT/SDR) e confirmar DRD/LEM.</a:t>
+              <a:t>•  Padronizar cadastro na origem (NVM/SDL → NMT/SDR).</a:t>
             </a:r>
           </a:p>
         </p:txBody>

</xml_diff>

<commit_message>
Ajustes de texto: Segurança + PCM e critério de escopo (ISO 340)
- Fechamento agora cita 'Segurança e PCM' acionados.
- Dourados e LEM descritos como sem itens críticos (reprovados no ensaio
  ISO 340) nesta 1ª etapa, em vez de 'sem pendências'. Atualiza slide de
  ação, obs de reconciliação e imagem de escopo.

Co-Authored-By: Claude Opus 4.8 <noreply@anthropic.com>
Claude-Session: https://claude.ai/code/session_01JAKYhBZ2VtJTfAk2iunizq
</commit_message>
<xml_diff>
--- a/plano_seguranca/Apresentacao_Estrategica_Correias_INPASA.pptx
+++ b/plano_seguranca/Apresentacao_Estrategica_Correias_INPASA.pptx
@@ -11315,7 +11315,7 @@
                 </a:solidFill>
                 <a:latin typeface="Montserrat"/>
               </a:rPr>
-              <a:t>Obs.: R$ 6,15 mi = somente as correias (material) — montagem com mão de obra interna, apenas vulcanização externa · Dourados (DRD) e LEM sem pendências (fora do escopo) · cadastro do dashboard usa NVM/SDL → padronizar p/ NMT/SDR · 1 dos 46 é sobressalente em estoque (45 esteiras físicas).</a:t>
+              <a:t>Obs.: R$ 6,15 mi = somente as correias (material) — montagem com mão de obra interna, apenas vulcanização externa · Dourados (DRD) e LEM sem itens críticos (reprovados ISO 340) nesta 1ª etapa · cadastro do dashboard usa NVM/SDL → padronizar p/ NMT/SDR · 1 dos 46 é sobressalente em estoque (45 esteiras físicas).</a:t>
             </a:r>
           </a:p>
         </p:txBody>
@@ -11958,7 +11958,7 @@
                 </a:solidFill>
                 <a:latin typeface="Montserrat"/>
               </a:rPr>
-              <a:t>•  PCM acionado para alinhar com TODAS as áreas cuidado reforçado até concluir a substituição das correias.</a:t>
+              <a:t>•  Segurança e PCM acionados para alinhar com TODAS as áreas cuidado reforçado até concluir a substituição das correias.</a:t>
             </a:r>
           </a:p>
         </p:txBody>

</xml_diff>